<commit_message>
Qwen PT/EN: slides 5 e 8 reescritos com cards; glossário técnico adicionado (11 slides)
</commit_message>
<xml_diff>
--- a/apresentacoes/Qwen_Medicina_Eric_EN.pptx
+++ b/apresentacoes/Qwen_Medicina_Eric_EN.pptx
@@ -15,9 +15,10 @@
     <p:sldId id="263" r:id="rId9"/>
     <p:sldId id="264" r:id="rId10"/>
     <p:sldId id="265" r:id="rId11"/>
+    <p:sldId id="266" r:id="rId12"/>
   </p:sldIdLst>
   <p:notesMasterIdLst>
-    <p:notesMasterId r:id="rId12"/>
+    <p:notesMasterId r:id="rId13"/>
   </p:notesMasterIdLst>
   <p:sldSz cx="12192000" cy="6858000"/>
   <p:notesSz cx="6858000" cy="12192000"/>
@@ -623,6 +624,94 @@
             <a:fld id="{F7021451-1387-4CA6-816F-3879F97B5CBC}" type="slidenum">
               <a:rPr lang="en-US"/>
               <a:t>10</a:t>
+            </a:fld>
+            <a:endParaRPr lang="en-US"/>
+          </a:p>
+        </p:txBody>
+      </p:sp>
+    </p:spTree>
+    <p:extLst>
+      <p:ext uri="{BB962C8B-B14F-4D97-AF65-F5344CB8AC3E}">
+        <p14:creationId xmlns:p14="http://schemas.microsoft.com/office/powerpoint/2010/main" val="1024086991"/>
+      </p:ext>
+    </p:extLst>
+  </p:cSld>
+  <p:clrMapOvr>
+    <a:masterClrMapping/>
+  </p:clrMapOvr>
+</p:notes>
+</file>
+
+<file path=ppt/notesSlides/notesSlide11.xml><?xml version="1.0" encoding="utf-8"?>
+<p:notes xmlns:a="http://schemas.openxmlformats.org/drawingml/2006/main" xmlns:r="http://schemas.openxmlformats.org/officeDocument/2006/relationships" xmlns:p="http://schemas.openxmlformats.org/presentationml/2006/main">
+  <p:cSld>
+    <p:spTree>
+      <p:nvGrpSpPr>
+        <p:cNvPr id="1" name=""/>
+        <p:cNvGrpSpPr/>
+        <p:nvPr/>
+      </p:nvGrpSpPr>
+      <p:grpSpPr>
+        <a:xfrm>
+          <a:off x="0" y="0"/>
+          <a:ext cx="0" cy="0"/>
+          <a:chOff x="0" y="0"/>
+          <a:chExt cx="0" cy="0"/>
+        </a:xfrm>
+      </p:grpSpPr>
+      <p:sp>
+        <p:nvSpPr>
+          <p:cNvPr id="2" name="Slide Image Placeholder 1"/>
+          <p:cNvSpPr>
+            <a:spLocks noGrp="1" noRot="1" noChangeAspect="1"/>
+          </p:cNvSpPr>
+          <p:nvPr>
+            <p:ph type="sldImg"/>
+          </p:nvPr>
+        </p:nvSpPr>
+        <p:spPr/>
+      </p:sp>
+      <p:sp>
+        <p:nvSpPr>
+          <p:cNvPr id="3" name="Notes Placeholder 2"/>
+          <p:cNvSpPr>
+            <a:spLocks noGrp="1"/>
+          </p:cNvSpPr>
+          <p:nvPr>
+            <p:ph type="body" idx="1"/>
+          </p:nvPr>
+        </p:nvSpPr>
+        <p:spPr/>
+        <p:txBody>
+          <a:bodyPr/>
+          <a:lstStyle/>
+          <a:p>
+            <a:r>
+              <a:rPr lang="en-US" dirty="0"/>
+              <a:t/>
+            </a:r>
+            <a:endParaRPr lang="en-US" dirty="0"/>
+          </a:p>
+        </p:txBody>
+      </p:sp>
+      <p:sp>
+        <p:nvSpPr>
+          <p:cNvPr id="4" name="Slide Number Placeholder 3"/>
+          <p:cNvSpPr>
+            <a:spLocks noGrp="1"/>
+          </p:cNvSpPr>
+          <p:nvPr>
+            <p:ph type="sldNum" sz="quarter" idx="10"/>
+          </p:nvPr>
+        </p:nvSpPr>
+        <p:spPr/>
+        <p:txBody>
+          <a:bodyPr/>
+          <a:lstStyle/>
+          <a:p>
+            <a:fld id="{F7021451-1387-4CA6-816F-3879F97B5CBC}" type="slidenum">
+              <a:rPr lang="en-US"/>
+              <a:t>11</a:t>
             </a:fld>
             <a:endParaRPr lang="en-US"/>
           </a:p>
@@ -2971,6 +3060,812 @@
 </p:sld>
 </file>
 
+<file path=ppt/slides/slide11.xml><?xml version="1.0" encoding="utf-8"?>
+<p:sld xmlns:a="http://schemas.openxmlformats.org/drawingml/2006/main" xmlns:r="http://schemas.openxmlformats.org/officeDocument/2006/relationships" xmlns:p="http://schemas.openxmlformats.org/presentationml/2006/main">
+  <p:cSld name="Slide 11">
+    <p:bg>
+      <p:bgPr>
+        <a:solidFill>
+          <a:srgbClr val="FFFFFF"/>
+        </a:solidFill>
+      </p:bgPr>
+    </p:bg>
+    <p:spTree>
+      <p:nvGrpSpPr>
+        <p:cNvPr id="1" name=""/>
+        <p:cNvGrpSpPr/>
+        <p:nvPr/>
+      </p:nvGrpSpPr>
+      <p:grpSpPr>
+        <a:xfrm>
+          <a:off x="0" y="0"/>
+          <a:ext cx="0" cy="0"/>
+          <a:chOff x="0" y="0"/>
+          <a:chExt cx="0" cy="0"/>
+        </a:xfrm>
+      </p:grpSpPr>
+      <p:sp>
+        <p:nvSpPr>
+          <p:cNvPr id="2" name="Text 0"/>
+          <p:cNvSpPr/>
+          <p:nvPr/>
+        </p:nvSpPr>
+        <p:spPr>
+          <a:xfrm>
+            <a:off x="548640" y="6446520"/>
+            <a:ext cx="5486400" cy="274320"/>
+          </a:xfrm>
+          <a:prstGeom prst="rect">
+            <a:avLst/>
+          </a:prstGeom>
+          <a:noFill/>
+          <a:ln/>
+        </p:spPr>
+        <p:txBody>
+          <a:bodyPr wrap="square" lIns="0" tIns="0" rIns="0" bIns="0" rtlCol="0" anchor="ctr"/>
+          <a:lstStyle/>
+          <a:p>
+            <a:pPr indent="0" marL="0">
+              <a:buNone/>
+            </a:pPr>
+            <a:r>
+              <a:rPr lang="en-US" sz="1000" dirty="0">
+                <a:solidFill>
+                  <a:srgbClr val="6B7280"/>
+                </a:solidFill>
+                <a:latin typeface="Arial" pitchFamily="34" charset="0"/>
+                <a:ea typeface="Arial" pitchFamily="34" charset="-122"/>
+                <a:cs typeface="Arial" pitchFamily="34" charset="-120"/>
+              </a:rPr>
+              <a:t>BeansTech · Qwen 3.8-Max · Confidencial</a:t>
+            </a:r>
+            <a:endParaRPr lang="en-US" sz="1000" dirty="0"/>
+          </a:p>
+        </p:txBody>
+      </p:sp>
+      <p:sp>
+        <p:nvSpPr>
+          <p:cNvPr id="3" name="Text 1"/>
+          <p:cNvSpPr/>
+          <p:nvPr/>
+        </p:nvSpPr>
+        <p:spPr>
+          <a:xfrm>
+            <a:off x="11091672" y="6446520"/>
+            <a:ext cx="548640" cy="274320"/>
+          </a:xfrm>
+          <a:prstGeom prst="rect">
+            <a:avLst/>
+          </a:prstGeom>
+          <a:noFill/>
+          <a:ln/>
+        </p:spPr>
+        <p:txBody>
+          <a:bodyPr wrap="square" lIns="0" tIns="0" rIns="0" bIns="0" rtlCol="0" anchor="ctr"/>
+          <a:lstStyle/>
+          <a:p>
+            <a:pPr algn="r" indent="0" marL="0">
+              <a:buNone/>
+            </a:pPr>
+            <a:r>
+              <a:rPr lang="en-US" sz="1000" dirty="0">
+                <a:solidFill>
+                  <a:srgbClr val="6B7280"/>
+                </a:solidFill>
+                <a:latin typeface="Arial" pitchFamily="34" charset="0"/>
+                <a:ea typeface="Arial" pitchFamily="34" charset="-122"/>
+                <a:cs typeface="Arial" pitchFamily="34" charset="-120"/>
+              </a:rPr>
+              <a:t>11</a:t>
+            </a:r>
+            <a:endParaRPr lang="en-US" sz="1000" dirty="0"/>
+          </a:p>
+        </p:txBody>
+      </p:sp>
+      <p:sp>
+        <p:nvSpPr>
+          <p:cNvPr id="4" name="Text 2"/>
+          <p:cNvSpPr/>
+          <p:nvPr/>
+        </p:nvSpPr>
+        <p:spPr>
+          <a:xfrm>
+            <a:off x="548640" y="365760"/>
+            <a:ext cx="11091672" cy="731520"/>
+          </a:xfrm>
+          <a:prstGeom prst="rect">
+            <a:avLst/>
+          </a:prstGeom>
+          <a:noFill/>
+          <a:ln/>
+        </p:spPr>
+        <p:txBody>
+          <a:bodyPr wrap="square" lIns="0" tIns="0" rIns="0" bIns="0" rtlCol="0" anchor="ctr"/>
+          <a:lstStyle/>
+          <a:p>
+            <a:pPr indent="0" marL="0">
+              <a:buNone/>
+            </a:pPr>
+            <a:r>
+              <a:rPr lang="en-US" sz="3000" b="1" dirty="0">
+                <a:solidFill>
+                  <a:srgbClr val="FF6A00"/>
+                </a:solidFill>
+                <a:latin typeface="Georgia" pitchFamily="34" charset="0"/>
+                <a:ea typeface="Georgia" pitchFamily="34" charset="-122"/>
+                <a:cs typeface="Georgia" pitchFamily="34" charset="-120"/>
+              </a:rPr>
+              <a:t>Technical Glossary</a:t>
+            </a:r>
+            <a:endParaRPr lang="en-US" sz="3000" dirty="0"/>
+          </a:p>
+        </p:txBody>
+      </p:sp>
+      <p:sp>
+        <p:nvSpPr>
+          <p:cNvPr id="5" name="Text 3"/>
+          <p:cNvSpPr/>
+          <p:nvPr/>
+        </p:nvSpPr>
+        <p:spPr>
+          <a:xfrm>
+            <a:off x="548640" y="1097280"/>
+            <a:ext cx="11091672" cy="457200"/>
+          </a:xfrm>
+          <a:prstGeom prst="rect">
+            <a:avLst/>
+          </a:prstGeom>
+          <a:noFill/>
+          <a:ln/>
+        </p:spPr>
+        <p:txBody>
+          <a:bodyPr wrap="square" lIns="0" tIns="0" rIns="0" bIns="0" rtlCol="0" anchor="ctr"/>
+          <a:lstStyle/>
+          <a:p>
+            <a:pPr indent="0" marL="0">
+              <a:buNone/>
+            </a:pPr>
+            <a:r>
+              <a:rPr lang="en-US" sz="1500" dirty="0">
+                <a:solidFill>
+                  <a:srgbClr val="4A5A57"/>
+                </a:solidFill>
+                <a:latin typeface="Arial" pitchFamily="34" charset="0"/>
+                <a:ea typeface="Arial" pitchFamily="34" charset="-122"/>
+                <a:cs typeface="Arial" pitchFamily="34" charset="-120"/>
+              </a:rPr>
+              <a:t>For reference during and after this presentation</a:t>
+            </a:r>
+            <a:endParaRPr lang="en-US" sz="1500" dirty="0"/>
+          </a:p>
+        </p:txBody>
+      </p:sp>
+      <p:sp>
+        <p:nvSpPr>
+          <p:cNvPr id="6" name="Shape 4"/>
+          <p:cNvSpPr/>
+          <p:nvPr/>
+        </p:nvSpPr>
+        <p:spPr>
+          <a:xfrm>
+            <a:off x="548640" y="1517904"/>
+            <a:ext cx="128016" cy="128016"/>
+          </a:xfrm>
+          <a:prstGeom prst="rect">
+            <a:avLst/>
+          </a:prstGeom>
+          <a:solidFill>
+            <a:srgbClr val="00A8E8"/>
+          </a:solidFill>
+          <a:ln w="12700">
+            <a:solidFill>
+              <a:srgbClr val="00A8E8"/>
+            </a:solidFill>
+            <a:prstDash val="solid"/>
+          </a:ln>
+        </p:spPr>
+      </p:sp>
+      <p:sp>
+        <p:nvSpPr>
+          <p:cNvPr id="7" name="Text 5"/>
+          <p:cNvSpPr/>
+          <p:nvPr/>
+        </p:nvSpPr>
+        <p:spPr>
+          <a:xfrm>
+            <a:off x="822960" y="1463040"/>
+            <a:ext cx="5029200" cy="320040"/>
+          </a:xfrm>
+          <a:prstGeom prst="rect">
+            <a:avLst/>
+          </a:prstGeom>
+          <a:noFill/>
+          <a:ln/>
+        </p:spPr>
+        <p:txBody>
+          <a:bodyPr wrap="square" lIns="0" tIns="0" rIns="0" bIns="0" rtlCol="0" anchor="ctr"/>
+          <a:lstStyle/>
+          <a:p>
+            <a:pPr indent="0" marL="0">
+              <a:buNone/>
+            </a:pPr>
+            <a:r>
+              <a:rPr lang="en-US" sz="1500" b="1" dirty="0">
+                <a:solidFill>
+                  <a:srgbClr val="FF6A00"/>
+                </a:solidFill>
+                <a:latin typeface="Arial" pitchFamily="34" charset="0"/>
+                <a:ea typeface="Arial" pitchFamily="34" charset="-122"/>
+                <a:cs typeface="Arial" pitchFamily="34" charset="-120"/>
+              </a:rPr>
+              <a:t>Coverage</a:t>
+            </a:r>
+            <a:endParaRPr lang="en-US" sz="1500" dirty="0"/>
+          </a:p>
+        </p:txBody>
+      </p:sp>
+      <p:sp>
+        <p:nvSpPr>
+          <p:cNvPr id="8" name="Text 6"/>
+          <p:cNvSpPr/>
+          <p:nvPr/>
+        </p:nvSpPr>
+        <p:spPr>
+          <a:xfrm>
+            <a:off x="822960" y="1810512"/>
+            <a:ext cx="5029200" cy="914400"/>
+          </a:xfrm>
+          <a:prstGeom prst="rect">
+            <a:avLst/>
+          </a:prstGeom>
+          <a:noFill/>
+          <a:ln/>
+        </p:spPr>
+        <p:txBody>
+          <a:bodyPr wrap="square" lIns="0" tIns="0" rIns="0" bIns="0" rtlCol="0" anchor="ctr"/>
+          <a:lstStyle/>
+          <a:p>
+            <a:pPr indent="0" marL="0">
+              <a:buNone/>
+            </a:pPr>
+            <a:r>
+              <a:rPr lang="en-US" sz="1150" dirty="0">
+                <a:solidFill>
+                  <a:srgbClr val="1B2A4A"/>
+                </a:solidFill>
+                <a:latin typeface="Arial" pitchFamily="34" charset="0"/>
+                <a:ea typeface="Arial" pitchFamily="34" charset="-122"/>
+                <a:cs typeface="Arial" pitchFamily="34" charset="-120"/>
+              </a:rPr>
+              <a:t>Fraction of the gold standard's critical claims present in the model's answer. Scale 0 to 1. Higher = more complete.</a:t>
+            </a:r>
+            <a:endParaRPr lang="en-US" sz="1150" dirty="0"/>
+          </a:p>
+        </p:txBody>
+      </p:sp>
+      <p:sp>
+        <p:nvSpPr>
+          <p:cNvPr id="9" name="Shape 7"/>
+          <p:cNvSpPr/>
+          <p:nvPr/>
+        </p:nvSpPr>
+        <p:spPr>
+          <a:xfrm>
+            <a:off x="6217920" y="1517904"/>
+            <a:ext cx="128016" cy="128016"/>
+          </a:xfrm>
+          <a:prstGeom prst="rect">
+            <a:avLst/>
+          </a:prstGeom>
+          <a:solidFill>
+            <a:srgbClr val="00A8E8"/>
+          </a:solidFill>
+          <a:ln w="12700">
+            <a:solidFill>
+              <a:srgbClr val="00A8E8"/>
+            </a:solidFill>
+            <a:prstDash val="solid"/>
+          </a:ln>
+        </p:spPr>
+      </p:sp>
+      <p:sp>
+        <p:nvSpPr>
+          <p:cNvPr id="10" name="Text 8"/>
+          <p:cNvSpPr/>
+          <p:nvPr/>
+        </p:nvSpPr>
+        <p:spPr>
+          <a:xfrm>
+            <a:off x="6492240" y="1463040"/>
+            <a:ext cx="5029200" cy="320040"/>
+          </a:xfrm>
+          <a:prstGeom prst="rect">
+            <a:avLst/>
+          </a:prstGeom>
+          <a:noFill/>
+          <a:ln/>
+        </p:spPr>
+        <p:txBody>
+          <a:bodyPr wrap="square" lIns="0" tIns="0" rIns="0" bIns="0" rtlCol="0" anchor="ctr"/>
+          <a:lstStyle/>
+          <a:p>
+            <a:pPr indent="0" marL="0">
+              <a:buNone/>
+            </a:pPr>
+            <a:r>
+              <a:rPr lang="en-US" sz="1500" b="1" dirty="0">
+                <a:solidFill>
+                  <a:srgbClr val="FF6A00"/>
+                </a:solidFill>
+                <a:latin typeface="Arial" pitchFamily="34" charset="0"/>
+                <a:ea typeface="Arial" pitchFamily="34" charset="-122"/>
+                <a:cs typeface="Arial" pitchFamily="34" charset="-120"/>
+              </a:rPr>
+              <a:t>Abstention</a:t>
+            </a:r>
+            <a:endParaRPr lang="en-US" sz="1500" dirty="0"/>
+          </a:p>
+        </p:txBody>
+      </p:sp>
+      <p:sp>
+        <p:nvSpPr>
+          <p:cNvPr id="11" name="Text 9"/>
+          <p:cNvSpPr/>
+          <p:nvPr/>
+        </p:nvSpPr>
+        <p:spPr>
+          <a:xfrm>
+            <a:off x="6492240" y="1810512"/>
+            <a:ext cx="5029200" cy="914400"/>
+          </a:xfrm>
+          <a:prstGeom prst="rect">
+            <a:avLst/>
+          </a:prstGeom>
+          <a:noFill/>
+          <a:ln/>
+        </p:spPr>
+        <p:txBody>
+          <a:bodyPr wrap="square" lIns="0" tIns="0" rIns="0" bIns="0" rtlCol="0" anchor="ctr"/>
+          <a:lstStyle/>
+          <a:p>
+            <a:pPr indent="0" marL="0">
+              <a:buNone/>
+            </a:pPr>
+            <a:r>
+              <a:rPr lang="en-US" sz="1150" dirty="0">
+                <a:solidFill>
+                  <a:srgbClr val="1B2A4A"/>
+                </a:solidFill>
+                <a:latin typeface="Arial" pitchFamily="34" charset="0"/>
+                <a:ea typeface="Arial" pitchFamily="34" charset="-122"/>
+                <a:cs typeface="Arial" pitchFamily="34" charset="-120"/>
+              </a:rPr>
+              <a:t>How many times the model correctly said 'I cannot determine this' when evidence was insufficient. More = safer.</a:t>
+            </a:r>
+            <a:endParaRPr lang="en-US" sz="1150" dirty="0"/>
+          </a:p>
+        </p:txBody>
+      </p:sp>
+      <p:sp>
+        <p:nvSpPr>
+          <p:cNvPr id="12" name="Shape 10"/>
+          <p:cNvSpPr/>
+          <p:nvPr/>
+        </p:nvSpPr>
+        <p:spPr>
+          <a:xfrm>
+            <a:off x="548640" y="2935224"/>
+            <a:ext cx="128016" cy="128016"/>
+          </a:xfrm>
+          <a:prstGeom prst="rect">
+            <a:avLst/>
+          </a:prstGeom>
+          <a:solidFill>
+            <a:srgbClr val="00A8E8"/>
+          </a:solidFill>
+          <a:ln w="12700">
+            <a:solidFill>
+              <a:srgbClr val="00A8E8"/>
+            </a:solidFill>
+            <a:prstDash val="solid"/>
+          </a:ln>
+        </p:spPr>
+      </p:sp>
+      <p:sp>
+        <p:nvSpPr>
+          <p:cNvPr id="13" name="Text 11"/>
+          <p:cNvSpPr/>
+          <p:nvPr/>
+        </p:nvSpPr>
+        <p:spPr>
+          <a:xfrm>
+            <a:off x="822960" y="2880360"/>
+            <a:ext cx="5029200" cy="320040"/>
+          </a:xfrm>
+          <a:prstGeom prst="rect">
+            <a:avLst/>
+          </a:prstGeom>
+          <a:noFill/>
+          <a:ln/>
+        </p:spPr>
+        <p:txBody>
+          <a:bodyPr wrap="square" lIns="0" tIns="0" rIns="0" bIns="0" rtlCol="0" anchor="ctr"/>
+          <a:lstStyle/>
+          <a:p>
+            <a:pPr indent="0" marL="0">
+              <a:buNone/>
+            </a:pPr>
+            <a:r>
+              <a:rPr lang="en-US" sz="1500" b="1" dirty="0">
+                <a:solidFill>
+                  <a:srgbClr val="FF6A00"/>
+                </a:solidFill>
+                <a:latin typeface="Arial" pitchFamily="34" charset="0"/>
+                <a:ea typeface="Arial" pitchFamily="34" charset="-122"/>
+                <a:cs typeface="Arial" pitchFamily="34" charset="-120"/>
+              </a:rPr>
+              <a:t>VQA (Visual Question Answering)</a:t>
+            </a:r>
+            <a:endParaRPr lang="en-US" sz="1500" dirty="0"/>
+          </a:p>
+        </p:txBody>
+      </p:sp>
+      <p:sp>
+        <p:nvSpPr>
+          <p:cNvPr id="14" name="Text 12"/>
+          <p:cNvSpPr/>
+          <p:nvPr/>
+        </p:nvSpPr>
+        <p:spPr>
+          <a:xfrm>
+            <a:off x="822960" y="3227832"/>
+            <a:ext cx="5029200" cy="914400"/>
+          </a:xfrm>
+          <a:prstGeom prst="rect">
+            <a:avLst/>
+          </a:prstGeom>
+          <a:noFill/>
+          <a:ln/>
+        </p:spPr>
+        <p:txBody>
+          <a:bodyPr wrap="square" lIns="0" tIns="0" rIns="0" bIns="0" rtlCol="0" anchor="ctr"/>
+          <a:lstStyle/>
+          <a:p>
+            <a:pPr indent="0" marL="0">
+              <a:buNone/>
+            </a:pPr>
+            <a:r>
+              <a:rPr lang="en-US" sz="1150" dirty="0">
+                <a:solidFill>
+                  <a:srgbClr val="1B2A4A"/>
+                </a:solidFill>
+                <a:latin typeface="Arial" pitchFamily="34" charset="0"/>
+                <a:ea typeface="Arial" pitchFamily="34" charset="-122"/>
+                <a:cs typeface="Arial" pitchFamily="34" charset="-120"/>
+              </a:rPr>
+              <a:t>Task of answering questions about images. In medicine: interpreting X-rays, CTs, clinical photographs.</a:t>
+            </a:r>
+            <a:endParaRPr lang="en-US" sz="1150" dirty="0"/>
+          </a:p>
+        </p:txBody>
+      </p:sp>
+      <p:sp>
+        <p:nvSpPr>
+          <p:cNvPr id="15" name="Shape 13"/>
+          <p:cNvSpPr/>
+          <p:nvPr/>
+        </p:nvSpPr>
+        <p:spPr>
+          <a:xfrm>
+            <a:off x="6217920" y="2935224"/>
+            <a:ext cx="128016" cy="128016"/>
+          </a:xfrm>
+          <a:prstGeom prst="rect">
+            <a:avLst/>
+          </a:prstGeom>
+          <a:solidFill>
+            <a:srgbClr val="00A8E8"/>
+          </a:solidFill>
+          <a:ln w="12700">
+            <a:solidFill>
+              <a:srgbClr val="00A8E8"/>
+            </a:solidFill>
+            <a:prstDash val="solid"/>
+          </a:ln>
+        </p:spPr>
+      </p:sp>
+      <p:sp>
+        <p:nvSpPr>
+          <p:cNvPr id="16" name="Text 14"/>
+          <p:cNvSpPr/>
+          <p:nvPr/>
+        </p:nvSpPr>
+        <p:spPr>
+          <a:xfrm>
+            <a:off x="6492240" y="2880360"/>
+            <a:ext cx="5029200" cy="320040"/>
+          </a:xfrm>
+          <a:prstGeom prst="rect">
+            <a:avLst/>
+          </a:prstGeom>
+          <a:noFill/>
+          <a:ln/>
+        </p:spPr>
+        <p:txBody>
+          <a:bodyPr wrap="square" lIns="0" tIns="0" rIns="0" bIns="0" rtlCol="0" anchor="ctr"/>
+          <a:lstStyle/>
+          <a:p>
+            <a:pPr indent="0" marL="0">
+              <a:buNone/>
+            </a:pPr>
+            <a:r>
+              <a:rPr lang="en-US" sz="1500" b="1" dirty="0">
+                <a:solidFill>
+                  <a:srgbClr val="FF6A00"/>
+                </a:solidFill>
+                <a:latin typeface="Arial" pitchFamily="34" charset="0"/>
+                <a:ea typeface="Arial" pitchFamily="34" charset="-122"/>
+                <a:cs typeface="Arial" pitchFamily="34" charset="-120"/>
+              </a:rPr>
+              <a:t>MoE (Mixture of Experts)</a:t>
+            </a:r>
+            <a:endParaRPr lang="en-US" sz="1500" dirty="0"/>
+          </a:p>
+        </p:txBody>
+      </p:sp>
+      <p:sp>
+        <p:nvSpPr>
+          <p:cNvPr id="17" name="Text 15"/>
+          <p:cNvSpPr/>
+          <p:nvPr/>
+        </p:nvSpPr>
+        <p:spPr>
+          <a:xfrm>
+            <a:off x="6492240" y="3227832"/>
+            <a:ext cx="5029200" cy="914400"/>
+          </a:xfrm>
+          <a:prstGeom prst="rect">
+            <a:avLst/>
+          </a:prstGeom>
+          <a:noFill/>
+          <a:ln/>
+        </p:spPr>
+        <p:txBody>
+          <a:bodyPr wrap="square" lIns="0" tIns="0" rIns="0" bIns="0" rtlCol="0" anchor="ctr"/>
+          <a:lstStyle/>
+          <a:p>
+            <a:pPr indent="0" marL="0">
+              <a:buNone/>
+            </a:pPr>
+            <a:r>
+              <a:rPr lang="en-US" sz="1150" dirty="0">
+                <a:solidFill>
+                  <a:srgbClr val="1B2A4A"/>
+                </a:solidFill>
+                <a:latin typeface="Arial" pitchFamily="34" charset="0"/>
+                <a:ea typeface="Arial" pitchFamily="34" charset="-122"/>
+                <a:cs typeface="Arial" pitchFamily="34" charset="-120"/>
+              </a:rPr>
+              <a:t>Architecture where only a subset of 'experts' activates per token. Reduces compute while maintaining quality.</a:t>
+            </a:r>
+            <a:endParaRPr lang="en-US" sz="1150" dirty="0"/>
+          </a:p>
+        </p:txBody>
+      </p:sp>
+      <p:sp>
+        <p:nvSpPr>
+          <p:cNvPr id="18" name="Shape 16"/>
+          <p:cNvSpPr/>
+          <p:nvPr/>
+        </p:nvSpPr>
+        <p:spPr>
+          <a:xfrm>
+            <a:off x="548640" y="4352544"/>
+            <a:ext cx="128016" cy="128016"/>
+          </a:xfrm>
+          <a:prstGeom prst="rect">
+            <a:avLst/>
+          </a:prstGeom>
+          <a:solidFill>
+            <a:srgbClr val="00A8E8"/>
+          </a:solidFill>
+          <a:ln w="12700">
+            <a:solidFill>
+              <a:srgbClr val="00A8E8"/>
+            </a:solidFill>
+            <a:prstDash val="solid"/>
+          </a:ln>
+        </p:spPr>
+      </p:sp>
+      <p:sp>
+        <p:nvSpPr>
+          <p:cNvPr id="19" name="Text 17"/>
+          <p:cNvSpPr/>
+          <p:nvPr/>
+        </p:nvSpPr>
+        <p:spPr>
+          <a:xfrm>
+            <a:off x="822960" y="4297680"/>
+            <a:ext cx="5029200" cy="320040"/>
+          </a:xfrm>
+          <a:prstGeom prst="rect">
+            <a:avLst/>
+          </a:prstGeom>
+          <a:noFill/>
+          <a:ln/>
+        </p:spPr>
+        <p:txBody>
+          <a:bodyPr wrap="square" lIns="0" tIns="0" rIns="0" bIns="0" rtlCol="0" anchor="ctr"/>
+          <a:lstStyle/>
+          <a:p>
+            <a:pPr indent="0" marL="0">
+              <a:buNone/>
+            </a:pPr>
+            <a:r>
+              <a:rPr lang="en-US" sz="1500" b="1" dirty="0">
+                <a:solidFill>
+                  <a:srgbClr val="FF6A00"/>
+                </a:solidFill>
+                <a:latin typeface="Arial" pitchFamily="34" charset="0"/>
+                <a:ea typeface="Arial" pitchFamily="34" charset="-122"/>
+                <a:cs typeface="Arial" pitchFamily="34" charset="-120"/>
+              </a:rPr>
+              <a:t>Documented reasoning</a:t>
+            </a:r>
+            <a:endParaRPr lang="en-US" sz="1500" dirty="0"/>
+          </a:p>
+        </p:txBody>
+      </p:sp>
+      <p:sp>
+        <p:nvSpPr>
+          <p:cNvPr id="20" name="Text 18"/>
+          <p:cNvSpPr/>
+          <p:nvPr/>
+        </p:nvSpPr>
+        <p:spPr>
+          <a:xfrm>
+            <a:off x="822960" y="4645152"/>
+            <a:ext cx="5029200" cy="914400"/>
+          </a:xfrm>
+          <a:prstGeom prst="rect">
+            <a:avLst/>
+          </a:prstGeom>
+          <a:noFill/>
+          <a:ln/>
+        </p:spPr>
+        <p:txBody>
+          <a:bodyPr wrap="square" lIns="0" tIns="0" rIns="0" bIns="0" rtlCol="0" anchor="ctr"/>
+          <a:lstStyle/>
+          <a:p>
+            <a:pPr indent="0" marL="0">
+              <a:buNone/>
+            </a:pPr>
+            <a:r>
+              <a:rPr lang="en-US" sz="1150" dirty="0">
+                <a:solidFill>
+                  <a:srgbClr val="1B2A4A"/>
+                </a:solidFill>
+                <a:latin typeface="Arial" pitchFamily="34" charset="0"/>
+                <a:ea typeface="Arial" pitchFamily="34" charset="-122"/>
+                <a:cs typeface="Arial" pitchFamily="34" charset="-120"/>
+              </a:rPr>
+              <a:t>The model shows its step-by-step clinical reasoning before the answer. Essential for audit and compliance.</a:t>
+            </a:r>
+            <a:endParaRPr lang="en-US" sz="1150" dirty="0"/>
+          </a:p>
+        </p:txBody>
+      </p:sp>
+      <p:sp>
+        <p:nvSpPr>
+          <p:cNvPr id="21" name="Shape 19"/>
+          <p:cNvSpPr/>
+          <p:nvPr/>
+        </p:nvSpPr>
+        <p:spPr>
+          <a:xfrm>
+            <a:off x="6217920" y="4352544"/>
+            <a:ext cx="128016" cy="128016"/>
+          </a:xfrm>
+          <a:prstGeom prst="rect">
+            <a:avLst/>
+          </a:prstGeom>
+          <a:solidFill>
+            <a:srgbClr val="00A8E8"/>
+          </a:solidFill>
+          <a:ln w="12700">
+            <a:solidFill>
+              <a:srgbClr val="00A8E8"/>
+            </a:solidFill>
+            <a:prstDash val="solid"/>
+          </a:ln>
+        </p:spPr>
+      </p:sp>
+      <p:sp>
+        <p:nvSpPr>
+          <p:cNvPr id="22" name="Text 20"/>
+          <p:cNvSpPr/>
+          <p:nvPr/>
+        </p:nvSpPr>
+        <p:spPr>
+          <a:xfrm>
+            <a:off x="6492240" y="4297680"/>
+            <a:ext cx="5029200" cy="320040"/>
+          </a:xfrm>
+          <a:prstGeom prst="rect">
+            <a:avLst/>
+          </a:prstGeom>
+          <a:noFill/>
+          <a:ln/>
+        </p:spPr>
+        <p:txBody>
+          <a:bodyPr wrap="square" lIns="0" tIns="0" rIns="0" bIns="0" rtlCol="0" anchor="ctr"/>
+          <a:lstStyle/>
+          <a:p>
+            <a:pPr indent="0" marL="0">
+              <a:buNone/>
+            </a:pPr>
+            <a:r>
+              <a:rPr lang="en-US" sz="1500" b="1" dirty="0">
+                <a:solidFill>
+                  <a:srgbClr val="FF6A00"/>
+                </a:solidFill>
+                <a:latin typeface="Arial" pitchFamily="34" charset="0"/>
+                <a:ea typeface="Arial" pitchFamily="34" charset="-122"/>
+                <a:cs typeface="Arial" pitchFamily="34" charset="-120"/>
+              </a:rPr>
+              <a:t>Red-team</a:t>
+            </a:r>
+            <a:endParaRPr lang="en-US" sz="1500" dirty="0"/>
+          </a:p>
+        </p:txBody>
+      </p:sp>
+      <p:sp>
+        <p:nvSpPr>
+          <p:cNvPr id="23" name="Text 21"/>
+          <p:cNvSpPr/>
+          <p:nvPr/>
+        </p:nvSpPr>
+        <p:spPr>
+          <a:xfrm>
+            <a:off x="6492240" y="4645152"/>
+            <a:ext cx="5029200" cy="914400"/>
+          </a:xfrm>
+          <a:prstGeom prst="rect">
+            <a:avLst/>
+          </a:prstGeom>
+          <a:noFill/>
+          <a:ln/>
+        </p:spPr>
+        <p:txBody>
+          <a:bodyPr wrap="square" lIns="0" tIns="0" rIns="0" bIns="0" rtlCol="0" anchor="ctr"/>
+          <a:lstStyle/>
+          <a:p>
+            <a:pPr indent="0" marL="0">
+              <a:buNone/>
+            </a:pPr>
+            <a:r>
+              <a:rPr lang="en-US" sz="1150" dirty="0">
+                <a:solidFill>
+                  <a:srgbClr val="1B2A4A"/>
+                </a:solidFill>
+                <a:latin typeface="Arial" pitchFamily="34" charset="0"/>
+                <a:ea typeface="Arial" pitchFamily="34" charset="-122"/>
+                <a:cs typeface="Arial" pitchFamily="34" charset="-120"/>
+              </a:rPr>
+              <a:t>Adversarial testing: deliberately trying to make the model fail or produce dangerous content. Measures safety robustness.</a:t>
+            </a:r>
+            <a:endParaRPr lang="en-US" sz="1150" dirty="0"/>
+          </a:p>
+        </p:txBody>
+      </p:sp>
+    </p:spTree>
+  </p:cSld>
+  <p:clrMapOvr>
+    <a:masterClrMapping/>
+  </p:clrMapOvr>
+</p:sld>
+</file>
+
 <file path=ppt/slides/slide2.xml><?xml version="1.0" encoding="utf-8"?>
 <p:sld xmlns:a="http://schemas.openxmlformats.org/drawingml/2006/main" xmlns:r="http://schemas.openxmlformats.org/officeDocument/2006/relationships" xmlns:p="http://schemas.openxmlformats.org/presentationml/2006/main">
   <p:cSld name="Slide 2">
@@ -7613,7 +8508,7 @@
                 <a:ea typeface="Arial" pitchFamily="34" charset="-122"/>
                 <a:cs typeface="Arial" pitchFamily="34" charset="-120"/>
               </a:rPr>
-              <a:t>Coverage 0,75 — 3× better than 2nd place</a:t>
+              <a:t>Coverage 0.75 — 3× better than 2nd place</a:t>
             </a:r>
             <a:endParaRPr lang="en-US" sz="1500" dirty="0"/>
           </a:p>
@@ -7627,18 +8522,18 @@
         </p:nvSpPr>
         <p:spPr>
           <a:xfrm>
-            <a:off x="548640" y="1645920"/>
-            <a:ext cx="8229600" cy="548640"/>
+            <a:off x="548640" y="1463040"/>
+            <a:ext cx="5303520" cy="914400"/>
           </a:xfrm>
           <a:prstGeom prst="rect">
             <a:avLst/>
           </a:prstGeom>
           <a:solidFill>
-            <a:srgbClr val="FF6A00"/>
+            <a:srgbClr val="E8F5E9"/>
           </a:solidFill>
           <a:ln w="12700">
             <a:solidFill>
-              <a:srgbClr val="FF6A00"/>
+              <a:srgbClr val="2E7D32"/>
             </a:solidFill>
             <a:prstDash val="solid"/>
           </a:ln>
@@ -7652,24 +8547,24 @@
         </p:nvSpPr>
         <p:spPr>
           <a:xfrm>
-            <a:off x="548640" y="1600200"/>
-            <a:ext cx="2743200" cy="457200"/>
-          </a:xfrm>
-          <a:prstGeom prst="rect">
-            <a:avLst/>
-          </a:prstGeom>
-          <a:noFill/>
-          <a:ln/>
-        </p:spPr>
-        <p:txBody>
-          <a:bodyPr wrap="square" lIns="0" tIns="0" rIns="0" bIns="0" rtlCol="0" anchor="ctr"/>
-          <a:lstStyle/>
-          <a:p>
-            <a:pPr indent="0" marL="0">
-              <a:buNone/>
-            </a:pPr>
-            <a:r>
-              <a:rPr lang="en-US" sz="1400" dirty="0">
+            <a:off x="731520" y="1536192"/>
+            <a:ext cx="3200400" cy="320040"/>
+          </a:xfrm>
+          <a:prstGeom prst="rect">
+            <a:avLst/>
+          </a:prstGeom>
+          <a:noFill/>
+          <a:ln/>
+        </p:spPr>
+        <p:txBody>
+          <a:bodyPr wrap="square" lIns="0" tIns="0" rIns="0" bIns="0" rtlCol="0" anchor="ctr"/>
+          <a:lstStyle/>
+          <a:p>
+            <a:pPr indent="0" marL="0">
+              <a:buNone/>
+            </a:pPr>
+            <a:r>
+              <a:rPr lang="en-US" sz="1400" b="1" dirty="0">
                 <a:solidFill>
                   <a:srgbClr val="1B2A4A"/>
                 </a:solidFill>
@@ -7691,7 +8586,46 @@
         </p:nvSpPr>
         <p:spPr>
           <a:xfrm>
-            <a:off x="8869680" y="1600200"/>
+            <a:off x="731520" y="1874520"/>
+            <a:ext cx="1371600" cy="365760"/>
+          </a:xfrm>
+          <a:prstGeom prst="rect">
+            <a:avLst/>
+          </a:prstGeom>
+          <a:noFill/>
+          <a:ln/>
+        </p:spPr>
+        <p:txBody>
+          <a:bodyPr wrap="square" lIns="0" tIns="0" rIns="0" bIns="0" rtlCol="0" anchor="ctr"/>
+          <a:lstStyle/>
+          <a:p>
+            <a:pPr indent="0" marL="0">
+              <a:buNone/>
+            </a:pPr>
+            <a:r>
+              <a:rPr lang="en-US" sz="1800" b="1" dirty="0">
+                <a:solidFill>
+                  <a:srgbClr val="2E7D32"/>
+                </a:solidFill>
+                <a:latin typeface="Georgia" pitchFamily="34" charset="0"/>
+                <a:ea typeface="Georgia" pitchFamily="34" charset="-122"/>
+                <a:cs typeface="Georgia" pitchFamily="34" charset="-120"/>
+              </a:rPr>
+              <a:t>cov 0.75</a:t>
+            </a:r>
+            <a:endParaRPr lang="en-US" sz="1800" dirty="0"/>
+          </a:p>
+        </p:txBody>
+      </p:sp>
+      <p:sp>
+        <p:nvSpPr>
+          <p:cNvPr id="9" name="Text 7"/>
+          <p:cNvSpPr/>
+          <p:nvPr/>
+        </p:nvSpPr>
+        <p:spPr>
+          <a:xfrm>
+            <a:off x="4663440" y="1536192"/>
             <a:ext cx="914400" cy="457200"/>
           </a:xfrm>
           <a:prstGeom prst="rect">
@@ -7708,40 +8642,37 @@
               <a:buNone/>
             </a:pPr>
             <a:r>
-              <a:rPr lang="en-US" sz="1400" b="1" dirty="0">
-                <a:solidFill>
-                  <a:srgbClr val="FF6A00"/>
-                </a:solidFill>
-                <a:latin typeface="Arial" pitchFamily="34" charset="0"/>
-                <a:ea typeface="Arial" pitchFamily="34" charset="-122"/>
-                <a:cs typeface="Arial" pitchFamily="34" charset="-120"/>
-              </a:rPr>
-              <a:t>0,75</a:t>
-            </a:r>
-            <a:endParaRPr lang="en-US" sz="1400" dirty="0"/>
-          </a:p>
-        </p:txBody>
-      </p:sp>
-      <p:sp>
-        <p:nvSpPr>
-          <p:cNvPr id="9" name="Shape 7"/>
-          <p:cNvSpPr/>
-          <p:nvPr/>
-        </p:nvSpPr>
-        <p:spPr>
-          <a:xfrm>
-            <a:off x="548640" y="2468880"/>
-            <a:ext cx="2743200" cy="548640"/>
+              <a:rPr lang="en-US" sz="2400" dirty="0">
+                <a:solidFill>
+                  <a:srgbClr val="FFD700"/>
+                </a:solidFill>
+              </a:rPr>
+              <a:t>★</a:t>
+            </a:r>
+            <a:endParaRPr lang="en-US" sz="2400" dirty="0"/>
+          </a:p>
+        </p:txBody>
+      </p:sp>
+      <p:sp>
+        <p:nvSpPr>
+          <p:cNvPr id="10" name="Shape 8"/>
+          <p:cNvSpPr/>
+          <p:nvPr/>
+        </p:nvSpPr>
+        <p:spPr>
+          <a:xfrm>
+            <a:off x="6217920" y="1463040"/>
+            <a:ext cx="5303520" cy="914400"/>
           </a:xfrm>
           <a:prstGeom prst="rect">
             <a:avLst/>
           </a:prstGeom>
           <a:solidFill>
-            <a:srgbClr val="1B2A4A"/>
+            <a:srgbClr val="FFFFFF"/>
           </a:solidFill>
           <a:ln w="12700">
             <a:solidFill>
-              <a:srgbClr val="1B2A4A"/>
+              <a:srgbClr val="E0E0E0"/>
             </a:solidFill>
             <a:prstDash val="solid"/>
           </a:ln>
@@ -7749,14 +8680,14 @@
       </p:sp>
       <p:sp>
         <p:nvSpPr>
-          <p:cNvPr id="10" name="Text 8"/>
-          <p:cNvSpPr/>
-          <p:nvPr/>
-        </p:nvSpPr>
-        <p:spPr>
-          <a:xfrm>
-            <a:off x="548640" y="2423160"/>
-            <a:ext cx="2743200" cy="457200"/>
+          <p:cNvPr id="11" name="Text 9"/>
+          <p:cNvSpPr/>
+          <p:nvPr/>
+        </p:nvSpPr>
+        <p:spPr>
+          <a:xfrm>
+            <a:off x="6400800" y="1536192"/>
+            <a:ext cx="3200400" cy="320040"/>
           </a:xfrm>
           <a:prstGeom prst="rect">
             <a:avLst/>
@@ -7788,63 +8719,63 @@
       </p:sp>
       <p:sp>
         <p:nvSpPr>
-          <p:cNvPr id="11" name="Text 9"/>
-          <p:cNvSpPr/>
-          <p:nvPr/>
-        </p:nvSpPr>
-        <p:spPr>
-          <a:xfrm>
-            <a:off x="3383280" y="2423160"/>
-            <a:ext cx="914400" cy="457200"/>
-          </a:xfrm>
-          <a:prstGeom prst="rect">
-            <a:avLst/>
-          </a:prstGeom>
-          <a:noFill/>
-          <a:ln/>
-        </p:spPr>
-        <p:txBody>
-          <a:bodyPr wrap="square" lIns="0" tIns="0" rIns="0" bIns="0" rtlCol="0" anchor="ctr"/>
-          <a:lstStyle/>
-          <a:p>
-            <a:pPr indent="0" marL="0">
-              <a:buNone/>
-            </a:pPr>
-            <a:r>
-              <a:rPr lang="en-US" sz="1400" b="1" dirty="0">
-                <a:solidFill>
-                  <a:srgbClr val="1B2A4A"/>
-                </a:solidFill>
-                <a:latin typeface="Arial" pitchFamily="34" charset="0"/>
-                <a:ea typeface="Arial" pitchFamily="34" charset="-122"/>
-                <a:cs typeface="Arial" pitchFamily="34" charset="-120"/>
-              </a:rPr>
-              <a:t>0,25</a:t>
-            </a:r>
-            <a:endParaRPr lang="en-US" sz="1400" dirty="0"/>
-          </a:p>
-        </p:txBody>
-      </p:sp>
-      <p:sp>
-        <p:nvSpPr>
-          <p:cNvPr id="12" name="Shape 10"/>
-          <p:cNvSpPr/>
-          <p:nvPr/>
-        </p:nvSpPr>
-        <p:spPr>
-          <a:xfrm>
-            <a:off x="548640" y="3291840"/>
-            <a:ext cx="2743200" cy="548640"/>
+          <p:cNvPr id="12" name="Text 10"/>
+          <p:cNvSpPr/>
+          <p:nvPr/>
+        </p:nvSpPr>
+        <p:spPr>
+          <a:xfrm>
+            <a:off x="6400800" y="1874520"/>
+            <a:ext cx="1371600" cy="365760"/>
+          </a:xfrm>
+          <a:prstGeom prst="rect">
+            <a:avLst/>
+          </a:prstGeom>
+          <a:noFill/>
+          <a:ln/>
+        </p:spPr>
+        <p:txBody>
+          <a:bodyPr wrap="square" lIns="0" tIns="0" rIns="0" bIns="0" rtlCol="0" anchor="ctr"/>
+          <a:lstStyle/>
+          <a:p>
+            <a:pPr indent="0" marL="0">
+              <a:buNone/>
+            </a:pPr>
+            <a:r>
+              <a:rPr lang="en-US" sz="1800" b="1" dirty="0">
+                <a:solidFill>
+                  <a:srgbClr val="6B7280"/>
+                </a:solidFill>
+                <a:latin typeface="Georgia" pitchFamily="34" charset="0"/>
+                <a:ea typeface="Georgia" pitchFamily="34" charset="-122"/>
+                <a:cs typeface="Georgia" pitchFamily="34" charset="-120"/>
+              </a:rPr>
+              <a:t>cov 0.25</a:t>
+            </a:r>
+            <a:endParaRPr lang="en-US" sz="1800" dirty="0"/>
+          </a:p>
+        </p:txBody>
+      </p:sp>
+      <p:sp>
+        <p:nvSpPr>
+          <p:cNvPr id="13" name="Shape 11"/>
+          <p:cNvSpPr/>
+          <p:nvPr/>
+        </p:nvSpPr>
+        <p:spPr>
+          <a:xfrm>
+            <a:off x="548640" y="2560320"/>
+            <a:ext cx="5303520" cy="914400"/>
           </a:xfrm>
           <a:prstGeom prst="rect">
             <a:avLst/>
           </a:prstGeom>
           <a:solidFill>
-            <a:srgbClr val="1B2A4A"/>
+            <a:srgbClr val="FFFFFF"/>
           </a:solidFill>
           <a:ln w="12700">
             <a:solidFill>
-              <a:srgbClr val="1B2A4A"/>
+              <a:srgbClr val="E0E0E0"/>
             </a:solidFill>
             <a:prstDash val="solid"/>
           </a:ln>
@@ -7852,14 +8783,14 @@
       </p:sp>
       <p:sp>
         <p:nvSpPr>
-          <p:cNvPr id="13" name="Text 11"/>
-          <p:cNvSpPr/>
-          <p:nvPr/>
-        </p:nvSpPr>
-        <p:spPr>
-          <a:xfrm>
-            <a:off x="548640" y="3246120"/>
-            <a:ext cx="2743200" cy="457200"/>
+          <p:cNvPr id="14" name="Text 12"/>
+          <p:cNvSpPr/>
+          <p:nvPr/>
+        </p:nvSpPr>
+        <p:spPr>
+          <a:xfrm>
+            <a:off x="731520" y="2633472"/>
+            <a:ext cx="3200400" cy="320040"/>
           </a:xfrm>
           <a:prstGeom prst="rect">
             <a:avLst/>
@@ -7891,63 +8822,63 @@
       </p:sp>
       <p:sp>
         <p:nvSpPr>
-          <p:cNvPr id="14" name="Text 12"/>
-          <p:cNvSpPr/>
-          <p:nvPr/>
-        </p:nvSpPr>
-        <p:spPr>
-          <a:xfrm>
-            <a:off x="3383280" y="3246120"/>
-            <a:ext cx="914400" cy="457200"/>
-          </a:xfrm>
-          <a:prstGeom prst="rect">
-            <a:avLst/>
-          </a:prstGeom>
-          <a:noFill/>
-          <a:ln/>
-        </p:spPr>
-        <p:txBody>
-          <a:bodyPr wrap="square" lIns="0" tIns="0" rIns="0" bIns="0" rtlCol="0" anchor="ctr"/>
-          <a:lstStyle/>
-          <a:p>
-            <a:pPr indent="0" marL="0">
-              <a:buNone/>
-            </a:pPr>
-            <a:r>
-              <a:rPr lang="en-US" sz="1400" b="1" dirty="0">
-                <a:solidFill>
-                  <a:srgbClr val="1B2A4A"/>
-                </a:solidFill>
-                <a:latin typeface="Arial" pitchFamily="34" charset="0"/>
-                <a:ea typeface="Arial" pitchFamily="34" charset="-122"/>
-                <a:cs typeface="Arial" pitchFamily="34" charset="-120"/>
-              </a:rPr>
-              <a:t>0,25</a:t>
-            </a:r>
-            <a:endParaRPr lang="en-US" sz="1400" dirty="0"/>
-          </a:p>
-        </p:txBody>
-      </p:sp>
-      <p:sp>
-        <p:nvSpPr>
-          <p:cNvPr id="15" name="Shape 13"/>
-          <p:cNvSpPr/>
-          <p:nvPr/>
-        </p:nvSpPr>
-        <p:spPr>
-          <a:xfrm>
-            <a:off x="548640" y="4114800"/>
-            <a:ext cx="2743200" cy="548640"/>
+          <p:cNvPr id="15" name="Text 13"/>
+          <p:cNvSpPr/>
+          <p:nvPr/>
+        </p:nvSpPr>
+        <p:spPr>
+          <a:xfrm>
+            <a:off x="731520" y="2971800"/>
+            <a:ext cx="1371600" cy="365760"/>
+          </a:xfrm>
+          <a:prstGeom prst="rect">
+            <a:avLst/>
+          </a:prstGeom>
+          <a:noFill/>
+          <a:ln/>
+        </p:spPr>
+        <p:txBody>
+          <a:bodyPr wrap="square" lIns="0" tIns="0" rIns="0" bIns="0" rtlCol="0" anchor="ctr"/>
+          <a:lstStyle/>
+          <a:p>
+            <a:pPr indent="0" marL="0">
+              <a:buNone/>
+            </a:pPr>
+            <a:r>
+              <a:rPr lang="en-US" sz="1800" b="1" dirty="0">
+                <a:solidFill>
+                  <a:srgbClr val="6B7280"/>
+                </a:solidFill>
+                <a:latin typeface="Georgia" pitchFamily="34" charset="0"/>
+                <a:ea typeface="Georgia" pitchFamily="34" charset="-122"/>
+                <a:cs typeface="Georgia" pitchFamily="34" charset="-120"/>
+              </a:rPr>
+              <a:t>cov 0.25</a:t>
+            </a:r>
+            <a:endParaRPr lang="en-US" sz="1800" dirty="0"/>
+          </a:p>
+        </p:txBody>
+      </p:sp>
+      <p:sp>
+        <p:nvSpPr>
+          <p:cNvPr id="16" name="Shape 14"/>
+          <p:cNvSpPr/>
+          <p:nvPr/>
+        </p:nvSpPr>
+        <p:spPr>
+          <a:xfrm>
+            <a:off x="6217920" y="2560320"/>
+            <a:ext cx="5303520" cy="914400"/>
           </a:xfrm>
           <a:prstGeom prst="rect">
             <a:avLst/>
           </a:prstGeom>
           <a:solidFill>
-            <a:srgbClr val="1B2A4A"/>
+            <a:srgbClr val="FFFFFF"/>
           </a:solidFill>
           <a:ln w="12700">
             <a:solidFill>
-              <a:srgbClr val="1B2A4A"/>
+              <a:srgbClr val="E0E0E0"/>
             </a:solidFill>
             <a:prstDash val="solid"/>
           </a:ln>
@@ -7955,14 +8886,14 @@
       </p:sp>
       <p:sp>
         <p:nvSpPr>
-          <p:cNvPr id="16" name="Text 14"/>
-          <p:cNvSpPr/>
-          <p:nvPr/>
-        </p:nvSpPr>
-        <p:spPr>
-          <a:xfrm>
-            <a:off x="548640" y="4069080"/>
-            <a:ext cx="2743200" cy="457200"/>
+          <p:cNvPr id="17" name="Text 15"/>
+          <p:cNvSpPr/>
+          <p:nvPr/>
+        </p:nvSpPr>
+        <p:spPr>
+          <a:xfrm>
+            <a:off x="6400800" y="2633472"/>
+            <a:ext cx="3200400" cy="320040"/>
           </a:xfrm>
           <a:prstGeom prst="rect">
             <a:avLst/>
@@ -7994,14 +8925,76 @@
       </p:sp>
       <p:sp>
         <p:nvSpPr>
-          <p:cNvPr id="17" name="Text 15"/>
-          <p:cNvSpPr/>
-          <p:nvPr/>
-        </p:nvSpPr>
-        <p:spPr>
-          <a:xfrm>
-            <a:off x="3383280" y="4069080"/>
-            <a:ext cx="914400" cy="457200"/>
+          <p:cNvPr id="18" name="Text 16"/>
+          <p:cNvSpPr/>
+          <p:nvPr/>
+        </p:nvSpPr>
+        <p:spPr>
+          <a:xfrm>
+            <a:off x="6400800" y="2971800"/>
+            <a:ext cx="1371600" cy="365760"/>
+          </a:xfrm>
+          <a:prstGeom prst="rect">
+            <a:avLst/>
+          </a:prstGeom>
+          <a:noFill/>
+          <a:ln/>
+        </p:spPr>
+        <p:txBody>
+          <a:bodyPr wrap="square" lIns="0" tIns="0" rIns="0" bIns="0" rtlCol="0" anchor="ctr"/>
+          <a:lstStyle/>
+          <a:p>
+            <a:pPr indent="0" marL="0">
+              <a:buNone/>
+            </a:pPr>
+            <a:r>
+              <a:rPr lang="en-US" sz="1800" b="1" dirty="0">
+                <a:solidFill>
+                  <a:srgbClr val="6B7280"/>
+                </a:solidFill>
+                <a:latin typeface="Georgia" pitchFamily="34" charset="0"/>
+                <a:ea typeface="Georgia" pitchFamily="34" charset="-122"/>
+                <a:cs typeface="Georgia" pitchFamily="34" charset="-120"/>
+              </a:rPr>
+              <a:t>cov 0.25</a:t>
+            </a:r>
+            <a:endParaRPr lang="en-US" sz="1800" dirty="0"/>
+          </a:p>
+        </p:txBody>
+      </p:sp>
+      <p:sp>
+        <p:nvSpPr>
+          <p:cNvPr id="19" name="Shape 17"/>
+          <p:cNvSpPr/>
+          <p:nvPr/>
+        </p:nvSpPr>
+        <p:spPr>
+          <a:xfrm>
+            <a:off x="548640" y="3840480"/>
+            <a:ext cx="11091672" cy="0"/>
+          </a:xfrm>
+          <a:prstGeom prst="line">
+            <a:avLst/>
+          </a:prstGeom>
+          <a:noFill/>
+          <a:ln w="9525">
+            <a:solidFill>
+              <a:srgbClr val="E0E0E0"/>
+            </a:solidFill>
+            <a:prstDash val="solid"/>
+          </a:ln>
+        </p:spPr>
+      </p:sp>
+      <p:sp>
+        <p:nvSpPr>
+          <p:cNvPr id="20" name="Text 18"/>
+          <p:cNvSpPr/>
+          <p:nvPr/>
+        </p:nvSpPr>
+        <p:spPr>
+          <a:xfrm>
+            <a:off x="548640" y="4023360"/>
+            <a:ext cx="5029200" cy="457200"/>
           </a:xfrm>
           <a:prstGeom prst="rect">
             <a:avLst/>
@@ -8025,7 +9018,7 @@
                 <a:ea typeface="Arial" pitchFamily="34" charset="-122"/>
                 <a:cs typeface="Arial" pitchFamily="34" charset="-120"/>
               </a:rPr>
-              <a:t>0,25</a:t>
+              <a:t>Case: Severe COPD, FEV1 28%, frequent exacerbator.</a:t>
             </a:r>
             <a:endParaRPr lang="en-US" sz="1400" dirty="0"/>
           </a:p>
@@ -8033,30 +9026,30 @@
       </p:sp>
       <p:sp>
         <p:nvSpPr>
-          <p:cNvPr id="18" name="Text 16"/>
-          <p:cNvSpPr/>
-          <p:nvPr/>
-        </p:nvSpPr>
-        <p:spPr>
-          <a:xfrm>
-            <a:off x="548640" y="4754880"/>
-            <a:ext cx="11091672" cy="914400"/>
-          </a:xfrm>
-          <a:prstGeom prst="rect">
-            <a:avLst/>
-          </a:prstGeom>
-          <a:noFill/>
-          <a:ln/>
-        </p:spPr>
-        <p:txBody>
-          <a:bodyPr wrap="square" lIns="0" tIns="0" rIns="0" bIns="0" rtlCol="0" anchor="ctr"/>
-          <a:lstStyle/>
-          <a:p>
-            <a:pPr indent="0" marL="0">
-              <a:buNone/>
-            </a:pPr>
-            <a:r>
-              <a:rPr lang="en-US" sz="1500" dirty="0">
+          <p:cNvPr id="21" name="Text 19"/>
+          <p:cNvSpPr/>
+          <p:nvPr/>
+        </p:nvSpPr>
+        <p:spPr>
+          <a:xfrm>
+            <a:off x="548640" y="4480560"/>
+            <a:ext cx="5029200" cy="731520"/>
+          </a:xfrm>
+          <a:prstGeom prst="rect">
+            <a:avLst/>
+          </a:prstGeom>
+          <a:noFill/>
+          <a:ln/>
+        </p:spPr>
+        <p:txBody>
+          <a:bodyPr wrap="square" lIns="0" tIns="0" rIns="0" bIns="0" rtlCol="0" anchor="ctr"/>
+          <a:lstStyle/>
+          <a:p>
+            <a:pPr indent="0" marL="0">
+              <a:buNone/>
+            </a:pPr>
+            <a:r>
+              <a:rPr lang="en-US" sz="1300" dirty="0">
                 <a:solidFill>
                   <a:srgbClr val="1B2A4A"/>
                 </a:solidFill>
@@ -8064,9 +9057,115 @@
                 <a:ea typeface="Arial" pitchFamily="34" charset="-122"/>
                 <a:cs typeface="Arial" pitchFamily="34" charset="-120"/>
               </a:rPr>
-              <a:t>Case: DPOC grave, VEF1 28%, exacerbador frequente. O Qwen 3.8-Max was the only one to indicate all management steps: triple therapy (LABA+LAMA+CSI), rehabilitation, vaccination, oxygen therapy and transplant evaluation.</a:t>
-            </a:r>
-            <a:endParaRPr lang="en-US" sz="1500" dirty="0"/>
+              <a:t>Qwen 3.8-Max was the only model to indicate all management steps: triple therapy, rehabilitation, vaccination, oxygen therapy, and transplant evaluation.</a:t>
+            </a:r>
+            <a:endParaRPr lang="en-US" sz="1300" dirty="0"/>
+          </a:p>
+        </p:txBody>
+      </p:sp>
+      <p:sp>
+        <p:nvSpPr>
+          <p:cNvPr id="22" name="Text 20"/>
+          <p:cNvSpPr/>
+          <p:nvPr/>
+        </p:nvSpPr>
+        <p:spPr>
+          <a:xfrm>
+            <a:off x="5943600" y="4023360"/>
+            <a:ext cx="5669280" cy="731520"/>
+          </a:xfrm>
+          <a:prstGeom prst="rect">
+            <a:avLst/>
+          </a:prstGeom>
+          <a:noFill/>
+          <a:ln/>
+        </p:spPr>
+        <p:txBody>
+          <a:bodyPr wrap="square" lIns="0" tIns="0" rIns="0" bIns="0" rtlCol="0" anchor="ctr"/>
+          <a:lstStyle/>
+          <a:p>
+            <a:pPr indent="0" marL="0">
+              <a:buNone/>
+            </a:pPr>
+            <a:r>
+              <a:rPr lang="en-US" sz="1300" b="1" dirty="0">
+                <a:solidFill>
+                  <a:srgbClr val="FF6A00"/>
+                </a:solidFill>
+                <a:latin typeface="Arial" pitchFamily="34" charset="0"/>
+                <a:ea typeface="Arial" pitchFamily="34" charset="-122"/>
+                <a:cs typeface="Arial" pitchFamily="34" charset="-120"/>
+              </a:rPr>
+              <a:t>Clinical significance: </a:t>
+            </a:r>
+            <a:pPr indent="0" marL="0">
+              <a:buNone/>
+            </a:pPr>
+            <a:r>
+              <a:rPr lang="en-US" sz="1300" dirty="0">
+                <a:solidFill>
+                  <a:srgbClr val="1B2A4A"/>
+                </a:solidFill>
+                <a:latin typeface="Arial" pitchFamily="34" charset="0"/>
+                <a:ea typeface="Arial" pitchFamily="34" charset="-122"/>
+                <a:cs typeface="Arial" pitchFamily="34" charset="-120"/>
+              </a:rPr>
+              <a:t>COPD affects 6% of Brazilians over 40. Missing a step costs hospitalizations and mortality.</a:t>
+            </a:r>
+            <a:endParaRPr lang="en-US" sz="1300" dirty="0"/>
+          </a:p>
+        </p:txBody>
+      </p:sp>
+      <p:sp>
+        <p:nvSpPr>
+          <p:cNvPr id="23" name="Text 21"/>
+          <p:cNvSpPr/>
+          <p:nvPr/>
+        </p:nvSpPr>
+        <p:spPr>
+          <a:xfrm>
+            <a:off x="5943600" y="4846320"/>
+            <a:ext cx="5669280" cy="548640"/>
+          </a:xfrm>
+          <a:prstGeom prst="rect">
+            <a:avLst/>
+          </a:prstGeom>
+          <a:noFill/>
+          <a:ln/>
+        </p:spPr>
+        <p:txBody>
+          <a:bodyPr wrap="square" lIns="0" tIns="0" rIns="0" bIns="0" rtlCol="0" anchor="ctr"/>
+          <a:lstStyle/>
+          <a:p>
+            <a:pPr indent="0" marL="0">
+              <a:buNone/>
+            </a:pPr>
+            <a:r>
+              <a:rPr lang="en-US" sz="1300" b="1" dirty="0">
+                <a:solidFill>
+                  <a:srgbClr val="FF6A00"/>
+                </a:solidFill>
+                <a:latin typeface="Arial" pitchFamily="34" charset="0"/>
+                <a:ea typeface="Arial" pitchFamily="34" charset="-122"/>
+                <a:cs typeface="Arial" pitchFamily="34" charset="-120"/>
+              </a:rPr>
+              <a:t>Where we use it: </a:t>
+            </a:r>
+            <a:pPr indent="0" marL="0">
+              <a:buNone/>
+            </a:pPr>
+            <a:r>
+              <a:rPr lang="en-US" sz="1300" dirty="0">
+                <a:solidFill>
+                  <a:srgbClr val="1B2A4A"/>
+                </a:solidFill>
+                <a:latin typeface="Arial" pitchFamily="34" charset="0"/>
+                <a:ea typeface="Arial" pitchFamily="34" charset="-122"/>
+                <a:cs typeface="Arial" pitchFamily="34" charset="-120"/>
+              </a:rPr>
+              <a:t>all health portals with respiratory cases. Standard model for pulmonology.</a:t>
+            </a:r>
+            <a:endParaRPr lang="en-US" sz="1300" dirty="0"/>
           </a:p>
         </p:txBody>
       </p:sp>
@@ -9547,7 +10646,7 @@
                 <a:ea typeface="Georgia" pitchFamily="34" charset="-122"/>
                 <a:cs typeface="Georgia" pitchFamily="34" charset="-120"/>
               </a:rPr>
-              <a:t>Lingshu-32B (base Qwen2.5-VL): imagem médica</a:t>
+              <a:t>Lingshu-32B (Qwen2.5-VL based): medical imaging</a:t>
             </a:r>
             <a:endParaRPr lang="en-US" sz="3000" dirty="0"/>
           </a:p>
@@ -9592,523 +10691,712 @@
           </a:p>
         </p:txBody>
       </p:sp>
-      <p:graphicFrame>
-        <p:nvGraphicFramePr>
-          <p:cNvPr id="9" name="Table 0"/>
-          <p:cNvGraphicFramePr>
-            <a:graphicFrameLocks noGrp="1"/>
-          </p:cNvGraphicFramePr>
-          <p:nvPr>
-            <p:extLst>
-              <p:ext uri="{D42A27DB-BD31-4B8C-83A1-F6EECF244321}">
-                <p14:modId xmlns:p14="http://schemas.microsoft.com/office/powerpoint/2010/main" val="1579011935"/>
-              </p:ext>
-            </p:extLst>
-          </p:nvPr>
-        </p:nvGraphicFramePr>
-        <p:xfrm>
-          <a:off x="548640" y="1371600"/>
-          <a:ext cx="11091672" cy="914400"/>
-        </p:xfrm>
-        <a:graphic>
-          <a:graphicData uri="http://schemas.openxmlformats.org/drawingml/2006/table">
-            <a:tbl>
-              <a:tblPr/>
-              <a:tblGrid>
-                <a:gridCol w="3657600"/>
-                <a:gridCol w="2743200"/>
-                <a:gridCol w="2743200"/>
-                <a:gridCol w="1856232"/>
-              </a:tblGrid>
-              <a:tr h="566928">
-                <a:tc>
-                  <a:txBody>
-                    <a:bodyPr/>
-                    <a:lstStyle/>
-                    <a:p>
-                      <a:pPr indent="0" marL="0">
-                        <a:buNone/>
-                      </a:pPr>
-                      <a:r>
-                        <a:rPr lang="en-US" sz="1300" b="1" dirty="0">
-                          <a:solidFill>
-                            <a:srgbClr val="FFFFFF"/>
-                          </a:solidFill>
-                          <a:latin typeface="Arial" pitchFamily="34" charset="0"/>
-                          <a:ea typeface="Arial" pitchFamily="34" charset="-122"/>
-                          <a:cs typeface="Arial" pitchFamily="34" charset="-120"/>
-                        </a:rPr>
-                        <a:t>Benchmark</a:t>
-                      </a:r>
-                      <a:endParaRPr lang="en-US" sz="1300" dirty="0">
-                        <a:latin typeface="Arial" charset="0"/>
-                        <a:ea typeface="Arial" charset="0"/>
-                        <a:cs typeface="Arial" charset="0"/>
-                      </a:endParaRPr>
-                    </a:p>
-                  </a:txBody>
-                  <a:tcPr marL="91440" marR="91440" marT="45720" marB="45720">
-                    <a:lnL w="6350" cap="flat" cmpd="sng" algn="ctr">
-                      <a:solidFill>
-                        <a:srgbClr val="E5E7EB"/>
-                      </a:solidFill>
-                      <a:prstDash val="solid"/>
-                      <a:round/>
-                      <a:headEnd type="none" w="med" len="med"/>
-                      <a:tailEnd type="none" w="med" len="med"/>
-                    </a:lnL>
-                    <a:lnR w="6350" cap="flat" cmpd="sng" algn="ctr">
-                      <a:solidFill>
-                        <a:srgbClr val="E5E7EB"/>
-                      </a:solidFill>
-                      <a:prstDash val="solid"/>
-                      <a:round/>
-                      <a:headEnd type="none" w="med" len="med"/>
-                      <a:tailEnd type="none" w="med" len="med"/>
-                    </a:lnR>
-                    <a:lnT w="6350" cap="flat" cmpd="sng" algn="ctr">
-                      <a:solidFill>
-                        <a:srgbClr val="E5E7EB"/>
-                      </a:solidFill>
-                      <a:prstDash val="solid"/>
-                      <a:round/>
-                      <a:headEnd type="none" w="med" len="med"/>
-                      <a:tailEnd type="none" w="med" len="med"/>
-                    </a:lnT>
-                    <a:lnB w="6350" cap="flat" cmpd="sng" algn="ctr">
-                      <a:solidFill>
-                        <a:srgbClr val="E5E7EB"/>
-                      </a:solidFill>
-                      <a:prstDash val="solid"/>
-                      <a:round/>
-                      <a:headEnd type="none" w="med" len="med"/>
-                      <a:tailEnd type="none" w="med" len="med"/>
-                    </a:lnB>
-                    <a:solidFill>
-                      <a:srgbClr val="1B2A4A"/>
-                    </a:solidFill>
-                  </a:tcPr>
-                </a:tc>
-                <a:tc>
-                  <a:txBody>
-                    <a:bodyPr/>
-                    <a:lstStyle/>
-                    <a:p>
-                      <a:pPr indent="0" marL="0">
-                        <a:buNone/>
-                      </a:pPr>
-                      <a:r>
-                        <a:rPr lang="en-US" sz="1300" b="1" dirty="0">
-                          <a:solidFill>
-                            <a:srgbClr val="FFFFFF"/>
-                          </a:solidFill>
-                          <a:latin typeface="Arial" pitchFamily="34" charset="0"/>
-                          <a:ea typeface="Arial" pitchFamily="34" charset="-122"/>
-                          <a:cs typeface="Arial" pitchFamily="34" charset="-120"/>
-                        </a:rPr>
-                        <a:t>Lingshu-32B</a:t>
-                      </a:r>
-                      <a:endParaRPr lang="en-US" sz="1300" dirty="0">
-                        <a:latin typeface="Arial" charset="0"/>
-                        <a:ea typeface="Arial" charset="0"/>
-                        <a:cs typeface="Arial" charset="0"/>
-                      </a:endParaRPr>
-                    </a:p>
-                  </a:txBody>
-                  <a:tcPr marL="91440" marR="91440" marT="45720" marB="45720">
-                    <a:lnL w="6350" cap="flat" cmpd="sng" algn="ctr">
-                      <a:solidFill>
-                        <a:srgbClr val="E5E7EB"/>
-                      </a:solidFill>
-                      <a:prstDash val="solid"/>
-                      <a:round/>
-                      <a:headEnd type="none" w="med" len="med"/>
-                      <a:tailEnd type="none" w="med" len="med"/>
-                    </a:lnL>
-                    <a:lnR w="6350" cap="flat" cmpd="sng" algn="ctr">
-                      <a:solidFill>
-                        <a:srgbClr val="E5E7EB"/>
-                      </a:solidFill>
-                      <a:prstDash val="solid"/>
-                      <a:round/>
-                      <a:headEnd type="none" w="med" len="med"/>
-                      <a:tailEnd type="none" w="med" len="med"/>
-                    </a:lnR>
-                    <a:lnT w="6350" cap="flat" cmpd="sng" algn="ctr">
-                      <a:solidFill>
-                        <a:srgbClr val="E5E7EB"/>
-                      </a:solidFill>
-                      <a:prstDash val="solid"/>
-                      <a:round/>
-                      <a:headEnd type="none" w="med" len="med"/>
-                      <a:tailEnd type="none" w="med" len="med"/>
-                    </a:lnT>
-                    <a:lnB w="6350" cap="flat" cmpd="sng" algn="ctr">
-                      <a:solidFill>
-                        <a:srgbClr val="E5E7EB"/>
-                      </a:solidFill>
-                      <a:prstDash val="solid"/>
-                      <a:round/>
-                      <a:headEnd type="none" w="med" len="med"/>
-                      <a:tailEnd type="none" w="med" len="med"/>
-                    </a:lnB>
-                    <a:solidFill>
-                      <a:srgbClr val="1B2A4A"/>
-                    </a:solidFill>
-                  </a:tcPr>
-                </a:tc>
-                <a:tc>
-                  <a:txBody>
-                    <a:bodyPr/>
-                    <a:lstStyle/>
-                    <a:p>
-                      <a:pPr indent="0" marL="0">
-                        <a:buNone/>
-                      </a:pPr>
-                      <a:r>
-                        <a:rPr lang="en-US" sz="1300" b="1" dirty="0">
-                          <a:solidFill>
-                            <a:srgbClr val="FFFFFF"/>
-                          </a:solidFill>
-                          <a:latin typeface="Arial" pitchFamily="34" charset="0"/>
-                          <a:ea typeface="Arial" pitchFamily="34" charset="-122"/>
-                          <a:cs typeface="Arial" pitchFamily="34" charset="-120"/>
-                        </a:rPr>
-                        <a:t>GPT-4.1</a:t>
-                      </a:r>
-                      <a:endParaRPr lang="en-US" sz="1300" dirty="0">
-                        <a:latin typeface="Arial" charset="0"/>
-                        <a:ea typeface="Arial" charset="0"/>
-                        <a:cs typeface="Arial" charset="0"/>
-                      </a:endParaRPr>
-                    </a:p>
-                  </a:txBody>
-                  <a:tcPr marL="91440" marR="91440" marT="45720" marB="45720">
-                    <a:lnL w="6350" cap="flat" cmpd="sng" algn="ctr">
-                      <a:solidFill>
-                        <a:srgbClr val="E5E7EB"/>
-                      </a:solidFill>
-                      <a:prstDash val="solid"/>
-                      <a:round/>
-                      <a:headEnd type="none" w="med" len="med"/>
-                      <a:tailEnd type="none" w="med" len="med"/>
-                    </a:lnL>
-                    <a:lnR w="6350" cap="flat" cmpd="sng" algn="ctr">
-                      <a:solidFill>
-                        <a:srgbClr val="E5E7EB"/>
-                      </a:solidFill>
-                      <a:prstDash val="solid"/>
-                      <a:round/>
-                      <a:headEnd type="none" w="med" len="med"/>
-                      <a:tailEnd type="none" w="med" len="med"/>
-                    </a:lnR>
-                    <a:lnT w="6350" cap="flat" cmpd="sng" algn="ctr">
-                      <a:solidFill>
-                        <a:srgbClr val="E5E7EB"/>
-                      </a:solidFill>
-                      <a:prstDash val="solid"/>
-                      <a:round/>
-                      <a:headEnd type="none" w="med" len="med"/>
-                      <a:tailEnd type="none" w="med" len="med"/>
-                    </a:lnT>
-                    <a:lnB w="6350" cap="flat" cmpd="sng" algn="ctr">
-                      <a:solidFill>
-                        <a:srgbClr val="E5E7EB"/>
-                      </a:solidFill>
-                      <a:prstDash val="solid"/>
-                      <a:round/>
-                      <a:headEnd type="none" w="med" len="med"/>
-                      <a:tailEnd type="none" w="med" len="med"/>
-                    </a:lnB>
-                    <a:solidFill>
-                      <a:srgbClr val="1B2A4A"/>
-                    </a:solidFill>
-                  </a:tcPr>
-                </a:tc>
-                <a:tc>
-                  <a:txBody>
-                    <a:bodyPr/>
-                    <a:lstStyle/>
-                    <a:p>
-                      <a:pPr indent="0" marL="0">
-                        <a:buNone/>
-                      </a:pPr>
-                      <a:r>
-                        <a:rPr lang="en-US" sz="1300" b="1" dirty="0">
-                          <a:solidFill>
-                            <a:srgbClr val="FFFFFF"/>
-                          </a:solidFill>
-                          <a:latin typeface="Arial" pitchFamily="34" charset="0"/>
-                          <a:ea typeface="Arial" pitchFamily="34" charset="-122"/>
-                          <a:cs typeface="Arial" pitchFamily="34" charset="-120"/>
-                        </a:rPr>
-                        <a:t>Claude Sonnet 4</a:t>
-                      </a:r>
-                      <a:endParaRPr lang="en-US" sz="1300" dirty="0">
-                        <a:latin typeface="Arial" charset="0"/>
-                        <a:ea typeface="Arial" charset="0"/>
-                        <a:cs typeface="Arial" charset="0"/>
-                      </a:endParaRPr>
-                    </a:p>
-                  </a:txBody>
-                  <a:tcPr marL="91440" marR="91440" marT="45720" marB="45720">
-                    <a:lnL w="6350" cap="flat" cmpd="sng" algn="ctr">
-                      <a:solidFill>
-                        <a:srgbClr val="E5E7EB"/>
-                      </a:solidFill>
-                      <a:prstDash val="solid"/>
-                      <a:round/>
-                      <a:headEnd type="none" w="med" len="med"/>
-                      <a:tailEnd type="none" w="med" len="med"/>
-                    </a:lnL>
-                    <a:lnR w="6350" cap="flat" cmpd="sng" algn="ctr">
-                      <a:solidFill>
-                        <a:srgbClr val="E5E7EB"/>
-                      </a:solidFill>
-                      <a:prstDash val="solid"/>
-                      <a:round/>
-                      <a:headEnd type="none" w="med" len="med"/>
-                      <a:tailEnd type="none" w="med" len="med"/>
-                    </a:lnR>
-                    <a:lnT w="6350" cap="flat" cmpd="sng" algn="ctr">
-                      <a:solidFill>
-                        <a:srgbClr val="E5E7EB"/>
-                      </a:solidFill>
-                      <a:prstDash val="solid"/>
-                      <a:round/>
-                      <a:headEnd type="none" w="med" len="med"/>
-                      <a:tailEnd type="none" w="med" len="med"/>
-                    </a:lnT>
-                    <a:lnB w="6350" cap="flat" cmpd="sng" algn="ctr">
-                      <a:solidFill>
-                        <a:srgbClr val="E5E7EB"/>
-                      </a:solidFill>
-                      <a:prstDash val="solid"/>
-                      <a:round/>
-                      <a:headEnd type="none" w="med" len="med"/>
-                      <a:tailEnd type="none" w="med" len="med"/>
-                    </a:lnB>
-                    <a:solidFill>
-                      <a:srgbClr val="1B2A4A"/>
-                    </a:solidFill>
-                  </a:tcPr>
-                </a:tc>
-              </a:tr>
-              <a:tr h="566928">
-                <a:tc>
-                  <a:txBody>
-                    <a:bodyPr/>
-                    <a:lstStyle/>
-                    <a:p>
-                      <a:pPr indent="0" marL="0">
-                        <a:buNone/>
-                      </a:pPr>
-                      <a:endParaRPr lang="en-US" sz="1200" dirty="0"/>
-                    </a:p>
-                  </a:txBody>
-                  <a:tcPr marL="91440" marR="91440" marT="45720" marB="45720">
-                    <a:lnL w="6350" cap="flat" cmpd="sng" algn="ctr">
-                      <a:solidFill>
-                        <a:srgbClr val="E5E7EB"/>
-                      </a:solidFill>
-                      <a:prstDash val="solid"/>
-                      <a:round/>
-                      <a:headEnd type="none" w="med" len="med"/>
-                      <a:tailEnd type="none" w="med" len="med"/>
-                    </a:lnL>
-                    <a:lnR w="6350" cap="flat" cmpd="sng" algn="ctr">
-                      <a:solidFill>
-                        <a:srgbClr val="E5E7EB"/>
-                      </a:solidFill>
-                      <a:prstDash val="solid"/>
-                      <a:round/>
-                      <a:headEnd type="none" w="med" len="med"/>
-                      <a:tailEnd type="none" w="med" len="med"/>
-                    </a:lnR>
-                    <a:lnT w="6350" cap="flat" cmpd="sng" algn="ctr">
-                      <a:solidFill>
-                        <a:srgbClr val="E5E7EB"/>
-                      </a:solidFill>
-                      <a:prstDash val="solid"/>
-                      <a:round/>
-                      <a:headEnd type="none" w="med" len="med"/>
-                      <a:tailEnd type="none" w="med" len="med"/>
-                    </a:lnT>
-                    <a:lnB w="6350" cap="flat" cmpd="sng" algn="ctr">
-                      <a:solidFill>
-                        <a:srgbClr val="E5E7EB"/>
-                      </a:solidFill>
-                      <a:prstDash val="solid"/>
-                      <a:round/>
-                      <a:headEnd type="none" w="med" len="med"/>
-                      <a:tailEnd type="none" w="med" len="med"/>
-                    </a:lnB>
-                  </a:tcPr>
-                </a:tc>
-                <a:tc>
-                  <a:txBody>
-                    <a:bodyPr/>
-                    <a:lstStyle/>
-                    <a:p>
-                      <a:pPr indent="0" marL="0">
-                        <a:buNone/>
-                      </a:pPr>
-                      <a:endParaRPr lang="en-US" sz="1200" dirty="0"/>
-                    </a:p>
-                  </a:txBody>
-                  <a:tcPr marL="91440" marR="91440" marT="45720" marB="45720">
-                    <a:lnL w="6350" cap="flat" cmpd="sng" algn="ctr">
-                      <a:solidFill>
-                        <a:srgbClr val="E5E7EB"/>
-                      </a:solidFill>
-                      <a:prstDash val="solid"/>
-                      <a:round/>
-                      <a:headEnd type="none" w="med" len="med"/>
-                      <a:tailEnd type="none" w="med" len="med"/>
-                    </a:lnL>
-                    <a:lnR w="6350" cap="flat" cmpd="sng" algn="ctr">
-                      <a:solidFill>
-                        <a:srgbClr val="E5E7EB"/>
-                      </a:solidFill>
-                      <a:prstDash val="solid"/>
-                      <a:round/>
-                      <a:headEnd type="none" w="med" len="med"/>
-                      <a:tailEnd type="none" w="med" len="med"/>
-                    </a:lnR>
-                    <a:lnT w="6350" cap="flat" cmpd="sng" algn="ctr">
-                      <a:solidFill>
-                        <a:srgbClr val="E5E7EB"/>
-                      </a:solidFill>
-                      <a:prstDash val="solid"/>
-                      <a:round/>
-                      <a:headEnd type="none" w="med" len="med"/>
-                      <a:tailEnd type="none" w="med" len="med"/>
-                    </a:lnT>
-                    <a:lnB w="6350" cap="flat" cmpd="sng" algn="ctr">
-                      <a:solidFill>
-                        <a:srgbClr val="E5E7EB"/>
-                      </a:solidFill>
-                      <a:prstDash val="solid"/>
-                      <a:round/>
-                      <a:headEnd type="none" w="med" len="med"/>
-                      <a:tailEnd type="none" w="med" len="med"/>
-                    </a:lnB>
-                  </a:tcPr>
-                </a:tc>
-                <a:tc>
-                  <a:txBody>
-                    <a:bodyPr/>
-                    <a:lstStyle/>
-                    <a:p>
-                      <a:pPr indent="0" marL="0">
-                        <a:buNone/>
-                      </a:pPr>
-                      <a:endParaRPr lang="en-US" sz="1200" dirty="0"/>
-                    </a:p>
-                  </a:txBody>
-                  <a:tcPr marL="91440" marR="91440" marT="45720" marB="45720">
-                    <a:lnL w="6350" cap="flat" cmpd="sng" algn="ctr">
-                      <a:solidFill>
-                        <a:srgbClr val="E5E7EB"/>
-                      </a:solidFill>
-                      <a:prstDash val="solid"/>
-                      <a:round/>
-                      <a:headEnd type="none" w="med" len="med"/>
-                      <a:tailEnd type="none" w="med" len="med"/>
-                    </a:lnL>
-                    <a:lnR w="6350" cap="flat" cmpd="sng" algn="ctr">
-                      <a:solidFill>
-                        <a:srgbClr val="E5E7EB"/>
-                      </a:solidFill>
-                      <a:prstDash val="solid"/>
-                      <a:round/>
-                      <a:headEnd type="none" w="med" len="med"/>
-                      <a:tailEnd type="none" w="med" len="med"/>
-                    </a:lnR>
-                    <a:lnT w="6350" cap="flat" cmpd="sng" algn="ctr">
-                      <a:solidFill>
-                        <a:srgbClr val="E5E7EB"/>
-                      </a:solidFill>
-                      <a:prstDash val="solid"/>
-                      <a:round/>
-                      <a:headEnd type="none" w="med" len="med"/>
-                      <a:tailEnd type="none" w="med" len="med"/>
-                    </a:lnT>
-                    <a:lnB w="6350" cap="flat" cmpd="sng" algn="ctr">
-                      <a:solidFill>
-                        <a:srgbClr val="E5E7EB"/>
-                      </a:solidFill>
-                      <a:prstDash val="solid"/>
-                      <a:round/>
-                      <a:headEnd type="none" w="med" len="med"/>
-                      <a:tailEnd type="none" w="med" len="med"/>
-                    </a:lnB>
-                  </a:tcPr>
-                </a:tc>
-                <a:tc>
-                  <a:txBody>
-                    <a:bodyPr/>
-                    <a:lstStyle/>
-                    <a:p>
-                      <a:pPr indent="0" marL="0">
-                        <a:buNone/>
-                      </a:pPr>
-                      <a:endParaRPr lang="en-US" sz="1200" dirty="0"/>
-                    </a:p>
-                  </a:txBody>
-                  <a:tcPr marL="91440" marR="91440" marT="45720" marB="45720">
-                    <a:lnL w="6350" cap="flat" cmpd="sng" algn="ctr">
-                      <a:solidFill>
-                        <a:srgbClr val="E5E7EB"/>
-                      </a:solidFill>
-                      <a:prstDash val="solid"/>
-                      <a:round/>
-                      <a:headEnd type="none" w="med" len="med"/>
-                      <a:tailEnd type="none" w="med" len="med"/>
-                    </a:lnL>
-                    <a:lnR w="6350" cap="flat" cmpd="sng" algn="ctr">
-                      <a:solidFill>
-                        <a:srgbClr val="E5E7EB"/>
-                      </a:solidFill>
-                      <a:prstDash val="solid"/>
-                      <a:round/>
-                      <a:headEnd type="none" w="med" len="med"/>
-                      <a:tailEnd type="none" w="med" len="med"/>
-                    </a:lnR>
-                    <a:lnT w="6350" cap="flat" cmpd="sng" algn="ctr">
-                      <a:solidFill>
-                        <a:srgbClr val="E5E7EB"/>
-                      </a:solidFill>
-                      <a:prstDash val="solid"/>
-                      <a:round/>
-                      <a:headEnd type="none" w="med" len="med"/>
-                      <a:tailEnd type="none" w="med" len="med"/>
-                    </a:lnT>
-                    <a:lnB w="6350" cap="flat" cmpd="sng" algn="ctr">
-                      <a:solidFill>
-                        <a:srgbClr val="E5E7EB"/>
-                      </a:solidFill>
-                      <a:prstDash val="solid"/>
-                      <a:round/>
-                      <a:headEnd type="none" w="med" len="med"/>
-                      <a:tailEnd type="none" w="med" len="med"/>
-                    </a:lnB>
-                  </a:tcPr>
-                </a:tc>
-              </a:tr>
-            </a:tbl>
-          </a:graphicData>
-        </a:graphic>
-      </p:graphicFrame>
-      <p:sp>
-        <p:nvSpPr>
-          <p:cNvPr id="7" name="Text 4"/>
-          <p:cNvSpPr/>
-          <p:nvPr/>
-        </p:nvSpPr>
-        <p:spPr>
-          <a:xfrm>
-            <a:off x="548640" y="4389120"/>
+      <p:sp>
+        <p:nvSpPr>
+          <p:cNvPr id="6" name="Shape 4"/>
+          <p:cNvSpPr/>
+          <p:nvPr/>
+        </p:nvSpPr>
+        <p:spPr>
+          <a:xfrm>
+            <a:off x="548640" y="1463040"/>
+            <a:ext cx="5303520" cy="914400"/>
+          </a:xfrm>
+          <a:prstGeom prst="rect">
+            <a:avLst/>
+          </a:prstGeom>
+          <a:solidFill>
+            <a:srgbClr val="E8F5E9"/>
+          </a:solidFill>
+          <a:ln w="12700">
+            <a:solidFill>
+              <a:srgbClr val="2E7D32"/>
+            </a:solidFill>
+            <a:prstDash val="solid"/>
+          </a:ln>
+        </p:spPr>
+      </p:sp>
+      <p:sp>
+        <p:nvSpPr>
+          <p:cNvPr id="7" name="Text 5"/>
+          <p:cNvSpPr/>
+          <p:nvPr/>
+        </p:nvSpPr>
+        <p:spPr>
+          <a:xfrm>
+            <a:off x="731520" y="1536192"/>
+            <a:ext cx="3200400" cy="320040"/>
+          </a:xfrm>
+          <a:prstGeom prst="rect">
+            <a:avLst/>
+          </a:prstGeom>
+          <a:noFill/>
+          <a:ln/>
+        </p:spPr>
+        <p:txBody>
+          <a:bodyPr wrap="square" lIns="0" tIns="0" rIns="0" bIns="0" rtlCol="0" anchor="ctr"/>
+          <a:lstStyle/>
+          <a:p>
+            <a:pPr indent="0" marL="0">
+              <a:buNone/>
+            </a:pPr>
+            <a:r>
+              <a:rPr lang="en-US" sz="1300" dirty="0">
+                <a:solidFill>
+                  <a:srgbClr val="1B2A4A"/>
+                </a:solidFill>
+                <a:latin typeface="Arial" pitchFamily="34" charset="0"/>
+                <a:ea typeface="Arial" pitchFamily="34" charset="-122"/>
+                <a:cs typeface="Arial" pitchFamily="34" charset="-120"/>
+              </a:rPr>
+              <a:t>VQA-RAD (radiology)</a:t>
+            </a:r>
+            <a:endParaRPr lang="en-US" sz="1300" dirty="0"/>
+          </a:p>
+        </p:txBody>
+      </p:sp>
+      <p:sp>
+        <p:nvSpPr>
+          <p:cNvPr id="8" name="Text 6"/>
+          <p:cNvSpPr/>
+          <p:nvPr/>
+        </p:nvSpPr>
+        <p:spPr>
+          <a:xfrm>
+            <a:off x="731520" y="1874520"/>
+            <a:ext cx="1371600" cy="365760"/>
+          </a:xfrm>
+          <a:prstGeom prst="rect">
+            <a:avLst/>
+          </a:prstGeom>
+          <a:noFill/>
+          <a:ln/>
+        </p:spPr>
+        <p:txBody>
+          <a:bodyPr wrap="square" lIns="0" tIns="0" rIns="0" bIns="0" rtlCol="0" anchor="ctr"/>
+          <a:lstStyle/>
+          <a:p>
+            <a:pPr indent="0" marL="0">
+              <a:buNone/>
+            </a:pPr>
+            <a:r>
+              <a:rPr lang="en-US" sz="2000" b="1" dirty="0">
+                <a:solidFill>
+                  <a:srgbClr val="2E7D32"/>
+                </a:solidFill>
+                <a:latin typeface="Georgia" pitchFamily="34" charset="0"/>
+                <a:ea typeface="Georgia" pitchFamily="34" charset="-122"/>
+                <a:cs typeface="Georgia" pitchFamily="34" charset="-120"/>
+              </a:rPr>
+              <a:t>76.5</a:t>
+            </a:r>
+            <a:endParaRPr lang="en-US" sz="2000" dirty="0"/>
+          </a:p>
+        </p:txBody>
+      </p:sp>
+      <p:sp>
+        <p:nvSpPr>
+          <p:cNvPr id="9" name="Text 7"/>
+          <p:cNvSpPr/>
+          <p:nvPr/>
+        </p:nvSpPr>
+        <p:spPr>
+          <a:xfrm>
+            <a:off x="2834640" y="1920240"/>
+            <a:ext cx="2743200" cy="274320"/>
+          </a:xfrm>
+          <a:prstGeom prst="rect">
+            <a:avLst/>
+          </a:prstGeom>
+          <a:noFill/>
+          <a:ln/>
+        </p:spPr>
+        <p:txBody>
+          <a:bodyPr wrap="square" lIns="0" tIns="0" rIns="0" bIns="0" rtlCol="0" anchor="ctr"/>
+          <a:lstStyle/>
+          <a:p>
+            <a:pPr indent="0" marL="0">
+              <a:buNone/>
+            </a:pPr>
+            <a:r>
+              <a:rPr lang="en-US" sz="1100" dirty="0">
+                <a:solidFill>
+                  <a:srgbClr val="6B7280"/>
+                </a:solidFill>
+                <a:latin typeface="Arial" pitchFamily="34" charset="0"/>
+                <a:ea typeface="Arial" pitchFamily="34" charset="-122"/>
+                <a:cs typeface="Arial" pitchFamily="34" charset="-120"/>
+              </a:rPr>
+              <a:t>GPT-4.1: 65.0</a:t>
+            </a:r>
+            <a:endParaRPr lang="en-US" sz="1100" dirty="0"/>
+          </a:p>
+        </p:txBody>
+      </p:sp>
+      <p:sp>
+        <p:nvSpPr>
+          <p:cNvPr id="10" name="Shape 8"/>
+          <p:cNvSpPr/>
+          <p:nvPr/>
+        </p:nvSpPr>
+        <p:spPr>
+          <a:xfrm>
+            <a:off x="6217920" y="1463040"/>
+            <a:ext cx="5303520" cy="914400"/>
+          </a:xfrm>
+          <a:prstGeom prst="rect">
+            <a:avLst/>
+          </a:prstGeom>
+          <a:solidFill>
+            <a:srgbClr val="E8F5E9"/>
+          </a:solidFill>
+          <a:ln w="12700">
+            <a:solidFill>
+              <a:srgbClr val="2E7D32"/>
+            </a:solidFill>
+            <a:prstDash val="solid"/>
+          </a:ln>
+        </p:spPr>
+      </p:sp>
+      <p:sp>
+        <p:nvSpPr>
+          <p:cNvPr id="11" name="Text 9"/>
+          <p:cNvSpPr/>
+          <p:nvPr/>
+        </p:nvSpPr>
+        <p:spPr>
+          <a:xfrm>
+            <a:off x="6400800" y="1536192"/>
+            <a:ext cx="3200400" cy="320040"/>
+          </a:xfrm>
+          <a:prstGeom prst="rect">
+            <a:avLst/>
+          </a:prstGeom>
+          <a:noFill/>
+          <a:ln/>
+        </p:spPr>
+        <p:txBody>
+          <a:bodyPr wrap="square" lIns="0" tIns="0" rIns="0" bIns="0" rtlCol="0" anchor="ctr"/>
+          <a:lstStyle/>
+          <a:p>
+            <a:pPr indent="0" marL="0">
+              <a:buNone/>
+            </a:pPr>
+            <a:r>
+              <a:rPr lang="en-US" sz="1300" dirty="0">
+                <a:solidFill>
+                  <a:srgbClr val="1B2A4A"/>
+                </a:solidFill>
+                <a:latin typeface="Arial" pitchFamily="34" charset="0"/>
+                <a:ea typeface="Arial" pitchFamily="34" charset="-122"/>
+                <a:cs typeface="Arial" pitchFamily="34" charset="-120"/>
+              </a:rPr>
+              <a:t>SLAKE (radiology)</a:t>
+            </a:r>
+            <a:endParaRPr lang="en-US" sz="1300" dirty="0"/>
+          </a:p>
+        </p:txBody>
+      </p:sp>
+      <p:sp>
+        <p:nvSpPr>
+          <p:cNvPr id="12" name="Text 10"/>
+          <p:cNvSpPr/>
+          <p:nvPr/>
+        </p:nvSpPr>
+        <p:spPr>
+          <a:xfrm>
+            <a:off x="6400800" y="1874520"/>
+            <a:ext cx="1371600" cy="365760"/>
+          </a:xfrm>
+          <a:prstGeom prst="rect">
+            <a:avLst/>
+          </a:prstGeom>
+          <a:noFill/>
+          <a:ln/>
+        </p:spPr>
+        <p:txBody>
+          <a:bodyPr wrap="square" lIns="0" tIns="0" rIns="0" bIns="0" rtlCol="0" anchor="ctr"/>
+          <a:lstStyle/>
+          <a:p>
+            <a:pPr indent="0" marL="0">
+              <a:buNone/>
+            </a:pPr>
+            <a:r>
+              <a:rPr lang="en-US" sz="2000" b="1" dirty="0">
+                <a:solidFill>
+                  <a:srgbClr val="2E7D32"/>
+                </a:solidFill>
+                <a:latin typeface="Georgia" pitchFamily="34" charset="0"/>
+                <a:ea typeface="Georgia" pitchFamily="34" charset="-122"/>
+                <a:cs typeface="Georgia" pitchFamily="34" charset="-120"/>
+              </a:rPr>
+              <a:t>89.2</a:t>
+            </a:r>
+            <a:endParaRPr lang="en-US" sz="2000" dirty="0"/>
+          </a:p>
+        </p:txBody>
+      </p:sp>
+      <p:sp>
+        <p:nvSpPr>
+          <p:cNvPr id="13" name="Text 11"/>
+          <p:cNvSpPr/>
+          <p:nvPr/>
+        </p:nvSpPr>
+        <p:spPr>
+          <a:xfrm>
+            <a:off x="8503920" y="1920240"/>
+            <a:ext cx="2743200" cy="274320"/>
+          </a:xfrm>
+          <a:prstGeom prst="rect">
+            <a:avLst/>
+          </a:prstGeom>
+          <a:noFill/>
+          <a:ln/>
+        </p:spPr>
+        <p:txBody>
+          <a:bodyPr wrap="square" lIns="0" tIns="0" rIns="0" bIns="0" rtlCol="0" anchor="ctr"/>
+          <a:lstStyle/>
+          <a:p>
+            <a:pPr indent="0" marL="0">
+              <a:buNone/>
+            </a:pPr>
+            <a:r>
+              <a:rPr lang="en-US" sz="1100" dirty="0">
+                <a:solidFill>
+                  <a:srgbClr val="6B7280"/>
+                </a:solidFill>
+                <a:latin typeface="Arial" pitchFamily="34" charset="0"/>
+                <a:ea typeface="Arial" pitchFamily="34" charset="-122"/>
+                <a:cs typeface="Arial" pitchFamily="34" charset="-120"/>
+              </a:rPr>
+              <a:t>GPT-4.1: 72.2</a:t>
+            </a:r>
+            <a:endParaRPr lang="en-US" sz="1100" dirty="0"/>
+          </a:p>
+        </p:txBody>
+      </p:sp>
+      <p:sp>
+        <p:nvSpPr>
+          <p:cNvPr id="14" name="Shape 12"/>
+          <p:cNvSpPr/>
+          <p:nvPr/>
+        </p:nvSpPr>
+        <p:spPr>
+          <a:xfrm>
+            <a:off x="548640" y="2560320"/>
+            <a:ext cx="5303520" cy="914400"/>
+          </a:xfrm>
+          <a:prstGeom prst="rect">
+            <a:avLst/>
+          </a:prstGeom>
+          <a:solidFill>
+            <a:srgbClr val="E8F5E9"/>
+          </a:solidFill>
+          <a:ln w="12700">
+            <a:solidFill>
+              <a:srgbClr val="2E7D32"/>
+            </a:solidFill>
+            <a:prstDash val="solid"/>
+          </a:ln>
+        </p:spPr>
+      </p:sp>
+      <p:sp>
+        <p:nvSpPr>
+          <p:cNvPr id="15" name="Text 13"/>
+          <p:cNvSpPr/>
+          <p:nvPr/>
+        </p:nvSpPr>
+        <p:spPr>
+          <a:xfrm>
+            <a:off x="731520" y="2633472"/>
+            <a:ext cx="3200400" cy="320040"/>
+          </a:xfrm>
+          <a:prstGeom prst="rect">
+            <a:avLst/>
+          </a:prstGeom>
+          <a:noFill/>
+          <a:ln/>
+        </p:spPr>
+        <p:txBody>
+          <a:bodyPr wrap="square" lIns="0" tIns="0" rIns="0" bIns="0" rtlCol="0" anchor="ctr"/>
+          <a:lstStyle/>
+          <a:p>
+            <a:pPr indent="0" marL="0">
+              <a:buNone/>
+            </a:pPr>
+            <a:r>
+              <a:rPr lang="en-US" sz="1300" dirty="0">
+                <a:solidFill>
+                  <a:srgbClr val="1B2A4A"/>
+                </a:solidFill>
+                <a:latin typeface="Arial" pitchFamily="34" charset="0"/>
+                <a:ea typeface="Arial" pitchFamily="34" charset="-122"/>
+                <a:cs typeface="Arial" pitchFamily="34" charset="-120"/>
+              </a:rPr>
+              <a:t>Average (7 benchmarks)</a:t>
+            </a:r>
+            <a:endParaRPr lang="en-US" sz="1300" dirty="0"/>
+          </a:p>
+        </p:txBody>
+      </p:sp>
+      <p:sp>
+        <p:nvSpPr>
+          <p:cNvPr id="16" name="Text 14"/>
+          <p:cNvSpPr/>
+          <p:nvPr/>
+        </p:nvSpPr>
+        <p:spPr>
+          <a:xfrm>
+            <a:off x="731520" y="2971800"/>
+            <a:ext cx="1371600" cy="365760"/>
+          </a:xfrm>
+          <a:prstGeom prst="rect">
+            <a:avLst/>
+          </a:prstGeom>
+          <a:noFill/>
+          <a:ln/>
+        </p:spPr>
+        <p:txBody>
+          <a:bodyPr wrap="square" lIns="0" tIns="0" rIns="0" bIns="0" rtlCol="0" anchor="ctr"/>
+          <a:lstStyle/>
+          <a:p>
+            <a:pPr indent="0" marL="0">
+              <a:buNone/>
+            </a:pPr>
+            <a:r>
+              <a:rPr lang="en-US" sz="2000" b="1" dirty="0">
+                <a:solidFill>
+                  <a:srgbClr val="2E7D32"/>
+                </a:solidFill>
+                <a:latin typeface="Georgia" pitchFamily="34" charset="0"/>
+                <a:ea typeface="Georgia" pitchFamily="34" charset="-122"/>
+                <a:cs typeface="Georgia" pitchFamily="34" charset="-120"/>
+              </a:rPr>
+              <a:t>66.6</a:t>
+            </a:r>
+            <a:endParaRPr lang="en-US" sz="2000" dirty="0"/>
+          </a:p>
+        </p:txBody>
+      </p:sp>
+      <p:sp>
+        <p:nvSpPr>
+          <p:cNvPr id="17" name="Text 15"/>
+          <p:cNvSpPr/>
+          <p:nvPr/>
+        </p:nvSpPr>
+        <p:spPr>
+          <a:xfrm>
+            <a:off x="2834640" y="3017520"/>
+            <a:ext cx="2743200" cy="274320"/>
+          </a:xfrm>
+          <a:prstGeom prst="rect">
+            <a:avLst/>
+          </a:prstGeom>
+          <a:noFill/>
+          <a:ln/>
+        </p:spPr>
+        <p:txBody>
+          <a:bodyPr wrap="square" lIns="0" tIns="0" rIns="0" bIns="0" rtlCol="0" anchor="ctr"/>
+          <a:lstStyle/>
+          <a:p>
+            <a:pPr indent="0" marL="0">
+              <a:buNone/>
+            </a:pPr>
+            <a:r>
+              <a:rPr lang="en-US" sz="1100" dirty="0">
+                <a:solidFill>
+                  <a:srgbClr val="6B7280"/>
+                </a:solidFill>
+                <a:latin typeface="Arial" pitchFamily="34" charset="0"/>
+                <a:ea typeface="Arial" pitchFamily="34" charset="-122"/>
+                <a:cs typeface="Arial" pitchFamily="34" charset="-120"/>
+              </a:rPr>
+              <a:t>GPT-4.1: 63.4</a:t>
+            </a:r>
+            <a:endParaRPr lang="en-US" sz="1100" dirty="0"/>
+          </a:p>
+        </p:txBody>
+      </p:sp>
+      <p:sp>
+        <p:nvSpPr>
+          <p:cNvPr id="18" name="Shape 16"/>
+          <p:cNvSpPr/>
+          <p:nvPr/>
+        </p:nvSpPr>
+        <p:spPr>
+          <a:xfrm>
+            <a:off x="6217920" y="2560320"/>
+            <a:ext cx="5303520" cy="914400"/>
+          </a:xfrm>
+          <a:prstGeom prst="rect">
+            <a:avLst/>
+          </a:prstGeom>
+          <a:solidFill>
+            <a:srgbClr val="E8F5E9"/>
+          </a:solidFill>
+          <a:ln w="12700">
+            <a:solidFill>
+              <a:srgbClr val="2E7D32"/>
+            </a:solidFill>
+            <a:prstDash val="solid"/>
+          </a:ln>
+        </p:spPr>
+      </p:sp>
+      <p:sp>
+        <p:nvSpPr>
+          <p:cNvPr id="19" name="Text 17"/>
+          <p:cNvSpPr/>
+          <p:nvPr/>
+        </p:nvSpPr>
+        <p:spPr>
+          <a:xfrm>
+            <a:off x="6400800" y="2633472"/>
+            <a:ext cx="3200400" cy="320040"/>
+          </a:xfrm>
+          <a:prstGeom prst="rect">
+            <a:avLst/>
+          </a:prstGeom>
+          <a:noFill/>
+          <a:ln/>
+        </p:spPr>
+        <p:txBody>
+          <a:bodyPr wrap="square" lIns="0" tIns="0" rIns="0" bIns="0" rtlCol="0" anchor="ctr"/>
+          <a:lstStyle/>
+          <a:p>
+            <a:pPr indent="0" marL="0">
+              <a:buNone/>
+            </a:pPr>
+            <a:r>
+              <a:rPr lang="en-US" sz="1300" dirty="0">
+                <a:solidFill>
+                  <a:srgbClr val="1B2A4A"/>
+                </a:solidFill>
+                <a:latin typeface="Arial" pitchFamily="34" charset="0"/>
+                <a:ea typeface="Arial" pitchFamily="34" charset="-122"/>
+                <a:cs typeface="Arial" pitchFamily="34" charset="-120"/>
+              </a:rPr>
+              <a:t>MIMIC-CXR (reports)</a:t>
+            </a:r>
+            <a:endParaRPr lang="en-US" sz="1300" dirty="0"/>
+          </a:p>
+        </p:txBody>
+      </p:sp>
+      <p:sp>
+        <p:nvSpPr>
+          <p:cNvPr id="20" name="Text 18"/>
+          <p:cNvSpPr/>
+          <p:nvPr/>
+        </p:nvSpPr>
+        <p:spPr>
+          <a:xfrm>
+            <a:off x="6400800" y="2971800"/>
+            <a:ext cx="1371600" cy="365760"/>
+          </a:xfrm>
+          <a:prstGeom prst="rect">
+            <a:avLst/>
+          </a:prstGeom>
+          <a:noFill/>
+          <a:ln/>
+        </p:spPr>
+        <p:txBody>
+          <a:bodyPr wrap="square" lIns="0" tIns="0" rIns="0" bIns="0" rtlCol="0" anchor="ctr"/>
+          <a:lstStyle/>
+          <a:p>
+            <a:pPr indent="0" marL="0">
+              <a:buNone/>
+            </a:pPr>
+            <a:r>
+              <a:rPr lang="en-US" sz="2000" b="1" dirty="0">
+                <a:solidFill>
+                  <a:srgbClr val="2E7D32"/>
+                </a:solidFill>
+                <a:latin typeface="Georgia" pitchFamily="34" charset="0"/>
+                <a:ea typeface="Georgia" pitchFamily="34" charset="-122"/>
+                <a:cs typeface="Georgia" pitchFamily="34" charset="-120"/>
+              </a:rPr>
+              <a:t>67.1</a:t>
+            </a:r>
+            <a:endParaRPr lang="en-US" sz="2000" dirty="0"/>
+          </a:p>
+        </p:txBody>
+      </p:sp>
+      <p:sp>
+        <p:nvSpPr>
+          <p:cNvPr id="21" name="Text 19"/>
+          <p:cNvSpPr/>
+          <p:nvPr/>
+        </p:nvSpPr>
+        <p:spPr>
+          <a:xfrm>
+            <a:off x="8503920" y="3017520"/>
+            <a:ext cx="2743200" cy="274320"/>
+          </a:xfrm>
+          <a:prstGeom prst="rect">
+            <a:avLst/>
+          </a:prstGeom>
+          <a:noFill/>
+          <a:ln/>
+        </p:spPr>
+        <p:txBody>
+          <a:bodyPr wrap="square" lIns="0" tIns="0" rIns="0" bIns="0" rtlCol="0" anchor="ctr"/>
+          <a:lstStyle/>
+          <a:p>
+            <a:pPr indent="0" marL="0">
+              <a:buNone/>
+            </a:pPr>
+            <a:r>
+              <a:rPr lang="en-US" sz="1100" dirty="0">
+                <a:solidFill>
+                  <a:srgbClr val="6B7280"/>
+                </a:solidFill>
+                <a:latin typeface="Arial" pitchFamily="34" charset="0"/>
+                <a:ea typeface="Arial" pitchFamily="34" charset="-122"/>
+                <a:cs typeface="Arial" pitchFamily="34" charset="-120"/>
+              </a:rPr>
+              <a:t>GPT-4.1: 57.1</a:t>
+            </a:r>
+            <a:endParaRPr lang="en-US" sz="1100" dirty="0"/>
+          </a:p>
+        </p:txBody>
+      </p:sp>
+      <p:sp>
+        <p:nvSpPr>
+          <p:cNvPr id="22" name="Shape 20"/>
+          <p:cNvSpPr/>
+          <p:nvPr/>
+        </p:nvSpPr>
+        <p:spPr>
+          <a:xfrm>
+            <a:off x="548640" y="3840480"/>
+            <a:ext cx="11091672" cy="0"/>
+          </a:xfrm>
+          <a:prstGeom prst="line">
+            <a:avLst/>
+          </a:prstGeom>
+          <a:noFill/>
+          <a:ln w="9525">
+            <a:solidFill>
+              <a:srgbClr val="E0E0E0"/>
+            </a:solidFill>
+            <a:prstDash val="solid"/>
+          </a:ln>
+        </p:spPr>
+      </p:sp>
+      <p:sp>
+        <p:nvSpPr>
+          <p:cNvPr id="23" name="Text 21"/>
+          <p:cNvSpPr/>
+          <p:nvPr/>
+        </p:nvSpPr>
+        <p:spPr>
+          <a:xfrm>
+            <a:off x="548640" y="4023360"/>
+            <a:ext cx="11091672" cy="548640"/>
+          </a:xfrm>
+          <a:prstGeom prst="rect">
+            <a:avLst/>
+          </a:prstGeom>
+          <a:noFill/>
+          <a:ln/>
+        </p:spPr>
+        <p:txBody>
+          <a:bodyPr wrap="square" lIns="0" tIns="0" rIns="0" bIns="0" rtlCol="0" anchor="ctr"/>
+          <a:lstStyle/>
+          <a:p>
+            <a:pPr indent="0" marL="0">
+              <a:buNone/>
+            </a:pPr>
+            <a:r>
+              <a:rPr lang="en-US" sz="1400" b="1" dirty="0">
+                <a:solidFill>
+                  <a:srgbClr val="FF6A00"/>
+                </a:solidFill>
+                <a:latin typeface="Arial" pitchFamily="34" charset="0"/>
+                <a:ea typeface="Arial" pitchFamily="34" charset="-122"/>
+                <a:cs typeface="Arial" pitchFamily="34" charset="-120"/>
+              </a:rPr>
+              <a:t>12 modalities: </a:t>
+            </a:r>
+            <a:pPr indent="0" marL="0">
+              <a:buNone/>
+            </a:pPr>
+            <a:r>
+              <a:rPr lang="en-US" sz="1300" dirty="0">
+                <a:solidFill>
+                  <a:srgbClr val="1B2A4A"/>
+                </a:solidFill>
+                <a:latin typeface="Arial" pitchFamily="34" charset="0"/>
+                <a:ea typeface="Arial" pitchFamily="34" charset="-122"/>
+                <a:cs typeface="Arial" pitchFamily="34" charset="-120"/>
+              </a:rPr>
+              <a:t>X-ray · CT · MRI · Ultrasound · Histopathology · Dermoscopy · Fundoscopy · OCT · Endoscopy · Microscopy · PET</a:t>
+            </a:r>
+            <a:endParaRPr lang="en-US" sz="1400" dirty="0"/>
+          </a:p>
+        </p:txBody>
+      </p:sp>
+      <p:sp>
+        <p:nvSpPr>
+          <p:cNvPr id="24" name="Text 22"/>
+          <p:cNvSpPr/>
+          <p:nvPr/>
+        </p:nvSpPr>
+        <p:spPr>
+          <a:xfrm>
+            <a:off x="548640" y="4754880"/>
+            <a:ext cx="11091672" cy="731520"/>
+          </a:xfrm>
+          <a:prstGeom prst="rect">
+            <a:avLst/>
+          </a:prstGeom>
+          <a:noFill/>
+          <a:ln/>
+        </p:spPr>
+        <p:txBody>
+          <a:bodyPr wrap="square" lIns="0" tIns="0" rIns="0" bIns="0" rtlCol="0" anchor="ctr"/>
+          <a:lstStyle/>
+          <a:p>
+            <a:pPr indent="0" marL="0">
+              <a:buNone/>
+            </a:pPr>
+            <a:r>
+              <a:rPr lang="en-US" sz="1400" b="1" dirty="0">
+                <a:solidFill>
+                  <a:srgbClr val="FF6A00"/>
+                </a:solidFill>
+                <a:latin typeface="Arial" pitchFamily="34" charset="0"/>
+                <a:ea typeface="Arial" pitchFamily="34" charset="-122"/>
+                <a:cs typeface="Arial" pitchFamily="34" charset="-120"/>
+              </a:rPr>
+              <a:t>Advantage: </a:t>
+            </a:r>
+            <a:pPr indent="0" marL="0">
+              <a:buNone/>
+            </a:pPr>
+            <a:r>
+              <a:rPr lang="en-US" sz="1300" dirty="0">
+                <a:solidFill>
+                  <a:srgbClr val="1B2A4A"/>
+                </a:solidFill>
+                <a:latin typeface="Arial" pitchFamily="34" charset="0"/>
+                <a:ea typeface="Arial" pitchFamily="34" charset="-122"/>
+                <a:cs typeface="Arial" pitchFamily="34" charset="-120"/>
+              </a:rPr>
+              <a:t>medical fine-tuning by DAMO Academy on Qwen2.5-VL — +10 points on benchmarks. The only open model that beats GPT-4.1 on medical VQA.</a:t>
+            </a:r>
+            <a:endParaRPr lang="en-US" sz="1400" dirty="0"/>
+          </a:p>
+        </p:txBody>
+      </p:sp>
+      <p:sp>
+        <p:nvSpPr>
+          <p:cNvPr id="25" name="Text 23"/>
+          <p:cNvSpPr/>
+          <p:nvPr/>
+        </p:nvSpPr>
+        <p:spPr>
+          <a:xfrm>
+            <a:off x="548640" y="5577840"/>
             <a:ext cx="11091672" cy="457200"/>
           </a:xfrm>
           <a:prstGeom prst="rect">
@@ -10125,7 +11413,7 @@
               <a:buNone/>
             </a:pPr>
             <a:r>
-              <a:rPr lang="en-US" sz="1400" b="1" dirty="0">
+              <a:rPr lang="en-US" sz="1300" b="1" dirty="0">
                 <a:solidFill>
                   <a:srgbClr val="FF6A00"/>
                 </a:solidFill>
@@ -10133,9 +11421,23 @@
                 <a:ea typeface="Arial" pitchFamily="34" charset="-122"/>
                 <a:cs typeface="Arial" pitchFamily="34" charset="-120"/>
               </a:rPr>
-              <a:t>12 modalities: RX · TC · RM · ultrassom · histopatologia · dermatoscopia · fundoscopia · OCT · endoscopia · microscopia · fotografia · PET</a:t>
-            </a:r>
-            <a:endParaRPr lang="en-US" sz="1400" dirty="0"/>
+              <a:t>Where we use it: </a:t>
+            </a:r>
+            <a:pPr indent="0" marL="0">
+              <a:buNone/>
+            </a:pPr>
+            <a:r>
+              <a:rPr lang="en-US" sz="1300" dirty="0">
+                <a:solidFill>
+                  <a:srgbClr val="1B2A4A"/>
+                </a:solidFill>
+                <a:latin typeface="Arial" pitchFamily="34" charset="0"/>
+                <a:ea typeface="Arial" pitchFamily="34" charset="-122"/>
+                <a:cs typeface="Arial" pitchFamily="34" charset="-120"/>
+              </a:rPr>
+              <a:t>exame.tech (diagnostic imaging) and dodr.ai (multimodal). Own GPU — 19.2s per analysis.</a:t>
+            </a:r>
+            <a:endParaRPr lang="en-US" sz="1300" dirty="0"/>
           </a:p>
         </p:txBody>
       </p:sp>

</xml_diff>